<commit_message>
Polish SV 90-day program deck
</commit_message>
<xml_diff>
--- a/outputs/SV_AI_Native_90일_실행프로그램.pptx
+++ b/outputs/SV_AI_Native_90일_실행프로그램.pptx
@@ -2,24 +2,24 @@
 <file path=ppt/presentation.xml><?xml version="1.0" encoding="utf-8"?>
 <p:presentation xmlns:p="http://schemas.openxmlformats.org/presentationml/2006/main">
   <p:sldMasterIdLst>
-    <p:sldMasterId xmlns:r="http://schemas.openxmlformats.org/officeDocument/2006/relationships" id="2147483648" r:id="R9b53f5988c8a4479"/>
+    <p:sldMasterId xmlns:r="http://schemas.openxmlformats.org/officeDocument/2006/relationships" id="2147483648" r:id="Rfba343f15b074f22"/>
   </p:sldMasterIdLst>
   <p:notesMasterIdLst>
-    <p:notesMasterId xmlns:r="http://schemas.openxmlformats.org/officeDocument/2006/relationships" r:id="R9643c3cc7ec7446e"/>
+    <p:notesMasterId xmlns:r="http://schemas.openxmlformats.org/officeDocument/2006/relationships" r:id="R7ebdc5ae4f4446b2"/>
   </p:notesMasterIdLst>
   <p:sldIdLst>
-    <p:sldId xmlns:r="http://schemas.openxmlformats.org/officeDocument/2006/relationships" id="256" r:id="Rb30692949b684c6e"/>
-    <p:sldId xmlns:r="http://schemas.openxmlformats.org/officeDocument/2006/relationships" id="257" r:id="R81b906a0f9a740de"/>
-    <p:sldId xmlns:r="http://schemas.openxmlformats.org/officeDocument/2006/relationships" id="258" r:id="R23d6452f10ca4040"/>
-    <p:sldId xmlns:r="http://schemas.openxmlformats.org/officeDocument/2006/relationships" id="259" r:id="Rf5879a2c44ce4031"/>
-    <p:sldId xmlns:r="http://schemas.openxmlformats.org/officeDocument/2006/relationships" id="260" r:id="R5e963c7ce6b24325"/>
-    <p:sldId xmlns:r="http://schemas.openxmlformats.org/officeDocument/2006/relationships" id="261" r:id="R751b44efdc454dd2"/>
-    <p:sldId xmlns:r="http://schemas.openxmlformats.org/officeDocument/2006/relationships" id="262" r:id="R358d8a1922224085"/>
-    <p:sldId xmlns:r="http://schemas.openxmlformats.org/officeDocument/2006/relationships" id="263" r:id="R78625fc1ae5449e9"/>
-    <p:sldId xmlns:r="http://schemas.openxmlformats.org/officeDocument/2006/relationships" id="264" r:id="R22ce4481edd74822"/>
-    <p:sldId xmlns:r="http://schemas.openxmlformats.org/officeDocument/2006/relationships" id="265" r:id="Rba58649a45a64e6b"/>
-    <p:sldId xmlns:r="http://schemas.openxmlformats.org/officeDocument/2006/relationships" id="266" r:id="R69a2198b85674246"/>
-    <p:sldId xmlns:r="http://schemas.openxmlformats.org/officeDocument/2006/relationships" id="267" r:id="Rce560c627c0b49f7"/>
+    <p:sldId xmlns:r="http://schemas.openxmlformats.org/officeDocument/2006/relationships" id="256" r:id="R3598233a5fe1478e"/>
+    <p:sldId xmlns:r="http://schemas.openxmlformats.org/officeDocument/2006/relationships" id="257" r:id="R49c7da08a61349a4"/>
+    <p:sldId xmlns:r="http://schemas.openxmlformats.org/officeDocument/2006/relationships" id="258" r:id="R493bdbd3451b4b8d"/>
+    <p:sldId xmlns:r="http://schemas.openxmlformats.org/officeDocument/2006/relationships" id="259" r:id="R8da841f78b2448c9"/>
+    <p:sldId xmlns:r="http://schemas.openxmlformats.org/officeDocument/2006/relationships" id="260" r:id="R4c21c0be14be47b6"/>
+    <p:sldId xmlns:r="http://schemas.openxmlformats.org/officeDocument/2006/relationships" id="261" r:id="R29a40334cf814ce3"/>
+    <p:sldId xmlns:r="http://schemas.openxmlformats.org/officeDocument/2006/relationships" id="262" r:id="R4b44fd715b5045ef"/>
+    <p:sldId xmlns:r="http://schemas.openxmlformats.org/officeDocument/2006/relationships" id="263" r:id="R0b600a0b8c9b4504"/>
+    <p:sldId xmlns:r="http://schemas.openxmlformats.org/officeDocument/2006/relationships" id="264" r:id="R7008f562907e447e"/>
+    <p:sldId xmlns:r="http://schemas.openxmlformats.org/officeDocument/2006/relationships" id="265" r:id="Rf6b69a29f72a471b"/>
+    <p:sldId xmlns:r="http://schemas.openxmlformats.org/officeDocument/2006/relationships" id="266" r:id="R9ccf89de9deb46e7"/>
+    <p:sldId xmlns:r="http://schemas.openxmlformats.org/officeDocument/2006/relationships" id="267" r:id="Rcaa7130ebc184bfd"/>
   </p:sldIdLst>
   <p:sldSz cx="12192000" cy="6858000"/>
   <p:notesSz cx="6858000" cy="9144000"/>
@@ -1338,7 +1338,7 @@
   </p:cSld>
   <p:clrMap bg1="lt1" tx1="dk1" bg2="lt2" tx2="dk2" accent1="accent1" accent2="accent2" accent3="accent3" accent4="accent4" accent5="accent5" accent6="accent6" hlink="hlink" folHlink="folHlink"/>
   <p:sldLayoutIdLst>
-    <p:sldLayoutId xmlns:r="http://schemas.openxmlformats.org/officeDocument/2006/relationships" id="2147483649" r:id="R368875ca54fc4839"/>
+    <p:sldLayoutId xmlns:r="http://schemas.openxmlformats.org/officeDocument/2006/relationships" id="2147483649" r:id="R6973991314c5452c"/>
   </p:sldLayoutIdLst>
   <p:txStyles>
     <p:titleStyle>
@@ -1979,6 +1979,7 @@
           <a:lstStyle xmlns:a="http://schemas.openxmlformats.org/drawingml/2006/main"/>
           <a:p xmlns:a="http://schemas.openxmlformats.org/drawingml/2006/main">
             <a:pPr algn="l">
+              <a:buNone/>
               <a:defRPr sz="1500" b="1">
                 <a:solidFill>
                   <a:srgbClr val="2F80ED"/>
@@ -2029,6 +2030,7 @@
           <a:lstStyle xmlns:a="http://schemas.openxmlformats.org/drawingml/2006/main"/>
           <a:p xmlns:a="http://schemas.openxmlformats.org/drawingml/2006/main">
             <a:pPr algn="l">
+              <a:buNone/>
               <a:defRPr sz="4350" b="1">
                 <a:solidFill>
                   <a:srgbClr val="0B1F3A"/>
@@ -2046,6 +2048,7 @@
           </a:p>
           <a:p xmlns:a="http://schemas.openxmlformats.org/drawingml/2006/main">
             <a:pPr algn="l">
+              <a:buNone/>
               <a:defRPr sz="4350" b="1">
                 <a:solidFill>
                   <a:srgbClr val="0B1F3A"/>
@@ -2127,6 +2130,7 @@
           <a:lstStyle xmlns:a="http://schemas.openxmlformats.org/drawingml/2006/main"/>
           <a:p xmlns:a="http://schemas.openxmlformats.org/drawingml/2006/main">
             <a:pPr algn="l">
+              <a:buNone/>
               <a:defRPr sz="2100" b="1">
                 <a:solidFill>
                   <a:srgbClr val="0E58C8"/>
@@ -2177,6 +2181,7 @@
           <a:lstStyle xmlns:a="http://schemas.openxmlformats.org/drawingml/2006/main"/>
           <a:p xmlns:a="http://schemas.openxmlformats.org/drawingml/2006/main">
             <a:pPr algn="l">
+              <a:buNone/>
               <a:defRPr sz="1650" b="0">
                 <a:solidFill>
                   <a:srgbClr val="5C6B7A"/>
@@ -2189,7 +2194,7 @@
                   <a:srgbClr val="5C6B7A"/>
                 </a:solidFill>
               </a:rPr>
-              <a:t>단순 PoC 제안이 아니라, SV 내부 실행 역량과 실증 산출물을 동시에 만드는 전환 프로그램</a:t>
+              <a:t>단순 PoC 제안이 아니라, SV 내부 실행 역량과 검증 가능한 산출물을 함께 만드는 전환 프로그램</a:t>
             </a:r>
           </a:p>
         </p:txBody>
@@ -2227,6 +2232,7 @@
           <a:lstStyle xmlns:a="http://schemas.openxmlformats.org/drawingml/2006/main"/>
           <a:p xmlns:a="http://schemas.openxmlformats.org/drawingml/2006/main">
             <a:pPr algn="r">
+              <a:buNone/>
               <a:defRPr sz="1500" b="1">
                 <a:solidFill>
                   <a:srgbClr val="0B1F3A"/>
@@ -2306,6 +2312,7 @@
           <a:lstStyle xmlns:a="http://schemas.openxmlformats.org/drawingml/2006/main"/>
           <a:p xmlns:a="http://schemas.openxmlformats.org/drawingml/2006/main">
             <a:pPr algn="l">
+              <a:buNone/>
               <a:defRPr sz="1050" b="1">
                 <a:solidFill>
                   <a:srgbClr val="2F80ED"/>
@@ -2356,6 +2363,7 @@
           <a:lstStyle xmlns:a="http://schemas.openxmlformats.org/drawingml/2006/main"/>
           <a:p xmlns:a="http://schemas.openxmlformats.org/drawingml/2006/main">
             <a:pPr algn="l">
+              <a:buNone/>
               <a:defRPr sz="2850" b="1">
                 <a:solidFill>
                   <a:srgbClr val="0B1F3A"/>
@@ -2368,7 +2376,7 @@
                   <a:srgbClr val="0B1F3A"/>
                 </a:solidFill>
               </a:rPr>
-              <a:t>SV 참여자별 명분</a:t>
+              <a:t>SV 참여자별 역할과 효익</a:t>
             </a:r>
           </a:p>
         </p:txBody>
@@ -2437,6 +2445,7 @@
           <a:lstStyle xmlns:a="http://schemas.openxmlformats.org/drawingml/2006/main"/>
           <a:p xmlns:a="http://schemas.openxmlformats.org/drawingml/2006/main">
             <a:pPr algn="r">
+              <a:buNone/>
               <a:defRPr sz="1350" b="1">
                 <a:solidFill>
                   <a:srgbClr val="2F80ED"/>
@@ -2487,6 +2496,7 @@
           <a:lstStyle xmlns:a="http://schemas.openxmlformats.org/drawingml/2006/main"/>
           <a:p xmlns:a="http://schemas.openxmlformats.org/drawingml/2006/main">
             <a:pPr algn="r">
+              <a:buNone/>
               <a:defRPr sz="1200" b="1">
                 <a:solidFill>
                   <a:srgbClr val="0B1F3A"/>
@@ -2568,6 +2578,7 @@
           <a:lstStyle xmlns:a="http://schemas.openxmlformats.org/drawingml/2006/main"/>
           <a:p xmlns:a="http://schemas.openxmlformats.org/drawingml/2006/main">
             <a:pPr algn="l">
+              <a:buNone/>
               <a:defRPr sz="975" b="0">
                 <a:solidFill>
                   <a:srgbClr val="5C6B7A"/>
@@ -2653,6 +2664,7 @@
           <a:lstStyle xmlns:a="http://schemas.openxmlformats.org/drawingml/2006/main"/>
           <a:p xmlns:a="http://schemas.openxmlformats.org/drawingml/2006/main">
             <a:pPr algn="l">
+              <a:buNone/>
               <a:defRPr sz="2100" b="1">
                 <a:solidFill>
                   <a:srgbClr val="0B1F3A"/>
@@ -2703,6 +2715,7 @@
           <a:lstStyle xmlns:a="http://schemas.openxmlformats.org/drawingml/2006/main"/>
           <a:p xmlns:a="http://schemas.openxmlformats.org/drawingml/2006/main">
             <a:pPr algn="l">
+              <a:buNone/>
               <a:defRPr sz="1425" b="0">
                 <a:solidFill>
                   <a:srgbClr val="5C6B7A"/>
@@ -2715,11 +2728,12 @@
                   <a:srgbClr val="5C6B7A"/>
                 </a:solidFill>
               </a:rPr>
-              <a:t>내 업무를 AI 처리 가능 단위로 나누는 법을 배웁니다.</a:t>
+              <a:t>내 업무를 AI가 보조할 수 있는 단위로 나누는 법을 배웁니다.</a:t>
             </a:r>
           </a:p>
           <a:p xmlns:a="http://schemas.openxmlformats.org/drawingml/2006/main">
             <a:pPr algn="l">
+              <a:buNone/>
               <a:defRPr sz="1425" b="0">
                 <a:solidFill>
                   <a:srgbClr val="5C6B7A"/>
@@ -2805,6 +2819,7 @@
           <a:lstStyle xmlns:a="http://schemas.openxmlformats.org/drawingml/2006/main"/>
           <a:p xmlns:a="http://schemas.openxmlformats.org/drawingml/2006/main">
             <a:pPr algn="l">
+              <a:buNone/>
               <a:defRPr sz="2100" b="1">
                 <a:solidFill>
                   <a:srgbClr val="0B1F3A"/>
@@ -2817,7 +2832,7 @@
                   <a:srgbClr val="0B1F3A"/>
                 </a:solidFill>
               </a:rPr>
-              <a:t>스텝조직</a:t>
+              <a:t>스태프 조직</a:t>
             </a:r>
           </a:p>
         </p:txBody>
@@ -2855,6 +2870,7 @@
           <a:lstStyle xmlns:a="http://schemas.openxmlformats.org/drawingml/2006/main"/>
           <a:p xmlns:a="http://schemas.openxmlformats.org/drawingml/2006/main">
             <a:pPr algn="l">
+              <a:buNone/>
               <a:defRPr sz="1425" b="0">
                 <a:solidFill>
                   <a:srgbClr val="5C6B7A"/>
@@ -2872,6 +2888,7 @@
           </a:p>
           <a:p xmlns:a="http://schemas.openxmlformats.org/drawingml/2006/main">
             <a:pPr algn="l">
+              <a:buNone/>
               <a:defRPr sz="1425" b="0">
                 <a:solidFill>
                   <a:srgbClr val="5C6B7A"/>
@@ -2884,7 +2901,7 @@
                   <a:srgbClr val="5C6B7A"/>
                 </a:solidFill>
               </a:rPr>
-              <a:t>보안, 템플릿, 로그 관리의 내부 오너가 됩니다.</a:t>
+              <a:t>보안, 템플릿, 로그 관리 기준을 맡습니다.</a:t>
             </a:r>
           </a:p>
         </p:txBody>
@@ -2955,6 +2972,7 @@
           <a:lstStyle xmlns:a="http://schemas.openxmlformats.org/drawingml/2006/main"/>
           <a:p xmlns:a="http://schemas.openxmlformats.org/drawingml/2006/main">
             <a:pPr algn="l">
+              <a:buNone/>
               <a:defRPr sz="2100" b="1">
                 <a:solidFill>
                   <a:srgbClr val="FFFFFF"/>
@@ -3005,6 +3023,7 @@
           <a:lstStyle xmlns:a="http://schemas.openxmlformats.org/drawingml/2006/main"/>
           <a:p xmlns:a="http://schemas.openxmlformats.org/drawingml/2006/main">
             <a:pPr algn="l">
+              <a:buNone/>
               <a:defRPr sz="1425" b="0">
                 <a:solidFill>
                   <a:srgbClr val="FFFFFF"/>
@@ -3017,11 +3036,12 @@
                   <a:srgbClr val="FFFFFF"/>
                 </a:solidFill>
               </a:rPr>
-              <a:t>일회성 교육이 아니라 내부 인력과 PoC 산출물이 남습니다.</a:t>
+              <a:t>일회성 교육이 아니라 내부 인력과 검증 산출물이 남습니다.</a:t>
             </a:r>
           </a:p>
           <a:p xmlns:a="http://schemas.openxmlformats.org/drawingml/2006/main">
             <a:pPr algn="l">
+              <a:buNone/>
               <a:defRPr sz="1425" b="0">
                 <a:solidFill>
                   <a:srgbClr val="FFFFFF"/>
@@ -3072,6 +3092,7 @@
           <a:lstStyle xmlns:a="http://schemas.openxmlformats.org/drawingml/2006/main"/>
           <a:p xmlns:a="http://schemas.openxmlformats.org/drawingml/2006/main">
             <a:pPr algn="ctr">
+              <a:buNone/>
               <a:defRPr sz="1875" b="1">
                 <a:solidFill>
                   <a:srgbClr val="0E58C8"/>
@@ -3151,6 +3172,7 @@
           <a:lstStyle xmlns:a="http://schemas.openxmlformats.org/drawingml/2006/main"/>
           <a:p xmlns:a="http://schemas.openxmlformats.org/drawingml/2006/main">
             <a:pPr algn="l">
+              <a:buNone/>
               <a:defRPr sz="1050" b="1">
                 <a:solidFill>
                   <a:srgbClr val="2F80ED"/>
@@ -3201,6 +3223,7 @@
           <a:lstStyle xmlns:a="http://schemas.openxmlformats.org/drawingml/2006/main"/>
           <a:p xmlns:a="http://schemas.openxmlformats.org/drawingml/2006/main">
             <a:pPr algn="l">
+              <a:buNone/>
               <a:defRPr sz="2850" b="1">
                 <a:solidFill>
                   <a:srgbClr val="0B1F3A"/>
@@ -3213,7 +3236,7 @@
                   <a:srgbClr val="0B1F3A"/>
                 </a:solidFill>
               </a:rPr>
-              <a:t>오늘 요청드리는 결정</a:t>
+              <a:t>오늘 정할 후속 검토 사항</a:t>
             </a:r>
           </a:p>
         </p:txBody>
@@ -3282,6 +3305,7 @@
           <a:lstStyle xmlns:a="http://schemas.openxmlformats.org/drawingml/2006/main"/>
           <a:p xmlns:a="http://schemas.openxmlformats.org/drawingml/2006/main">
             <a:pPr algn="r">
+              <a:buNone/>
               <a:defRPr sz="1350" b="1">
                 <a:solidFill>
                   <a:srgbClr val="2F80ED"/>
@@ -3332,6 +3356,7 @@
           <a:lstStyle xmlns:a="http://schemas.openxmlformats.org/drawingml/2006/main"/>
           <a:p xmlns:a="http://schemas.openxmlformats.org/drawingml/2006/main">
             <a:pPr algn="r">
+              <a:buNone/>
               <a:defRPr sz="1200" b="1">
                 <a:solidFill>
                   <a:srgbClr val="0B1F3A"/>
@@ -3413,6 +3438,7 @@
           <a:lstStyle xmlns:a="http://schemas.openxmlformats.org/drawingml/2006/main"/>
           <a:p xmlns:a="http://schemas.openxmlformats.org/drawingml/2006/main">
             <a:pPr algn="l">
+              <a:buNone/>
               <a:defRPr sz="975" b="0">
                 <a:solidFill>
                   <a:srgbClr val="5C6B7A"/>
@@ -3498,6 +3524,7 @@
           <a:lstStyle xmlns:a="http://schemas.openxmlformats.org/drawingml/2006/main"/>
           <a:p xmlns:a="http://schemas.openxmlformats.org/drawingml/2006/main">
             <a:pPr algn="ctr">
+              <a:buNone/>
               <a:defRPr sz="1500" b="1">
                 <a:solidFill>
                   <a:srgbClr val="2F80ED"/>
@@ -3548,6 +3575,7 @@
           <a:lstStyle xmlns:a="http://schemas.openxmlformats.org/drawingml/2006/main"/>
           <a:p xmlns:a="http://schemas.openxmlformats.org/drawingml/2006/main">
             <a:pPr algn="l">
+              <a:buNone/>
               <a:defRPr sz="1725" b="1">
                 <a:solidFill>
                   <a:srgbClr val="0B1F3A"/>
@@ -3633,6 +3661,7 @@
           <a:lstStyle xmlns:a="http://schemas.openxmlformats.org/drawingml/2006/main"/>
           <a:p xmlns:a="http://schemas.openxmlformats.org/drawingml/2006/main">
             <a:pPr algn="ctr">
+              <a:buNone/>
               <a:defRPr sz="1500" b="1">
                 <a:solidFill>
                   <a:srgbClr val="2F80ED"/>
@@ -3683,6 +3712,7 @@
           <a:lstStyle xmlns:a="http://schemas.openxmlformats.org/drawingml/2006/main"/>
           <a:p xmlns:a="http://schemas.openxmlformats.org/drawingml/2006/main">
             <a:pPr algn="l">
+              <a:buNone/>
               <a:defRPr sz="1725" b="1">
                 <a:solidFill>
                   <a:srgbClr val="0B1F3A"/>
@@ -3695,7 +3725,7 @@
                   <a:srgbClr val="0B1F3A"/>
                 </a:solidFill>
               </a:rPr>
-              <a:t>SV 내부 참여자 3-5명을 정할 수 있는가</a:t>
+              <a:t>SV 내부 참여 후보 3-5명을 정할 수 있는가</a:t>
             </a:r>
           </a:p>
         </p:txBody>
@@ -3768,6 +3798,7 @@
           <a:lstStyle xmlns:a="http://schemas.openxmlformats.org/drawingml/2006/main"/>
           <a:p xmlns:a="http://schemas.openxmlformats.org/drawingml/2006/main">
             <a:pPr algn="ctr">
+              <a:buNone/>
               <a:defRPr sz="1500" b="1">
                 <a:solidFill>
                   <a:srgbClr val="2F80ED"/>
@@ -3818,6 +3849,7 @@
           <a:lstStyle xmlns:a="http://schemas.openxmlformats.org/drawingml/2006/main"/>
           <a:p xmlns:a="http://schemas.openxmlformats.org/drawingml/2006/main">
             <a:pPr algn="l">
+              <a:buNone/>
               <a:defRPr sz="1725" b="1">
                 <a:solidFill>
                   <a:srgbClr val="0B1F3A"/>
@@ -3903,6 +3935,7 @@
           <a:lstStyle xmlns:a="http://schemas.openxmlformats.org/drawingml/2006/main"/>
           <a:p xmlns:a="http://schemas.openxmlformats.org/drawingml/2006/main">
             <a:pPr algn="ctr">
+              <a:buNone/>
               <a:defRPr sz="1500" b="1">
                 <a:solidFill>
                   <a:srgbClr val="2F80ED"/>
@@ -3953,6 +3986,7 @@
           <a:lstStyle xmlns:a="http://schemas.openxmlformats.org/drawingml/2006/main"/>
           <a:p xmlns:a="http://schemas.openxmlformats.org/drawingml/2006/main">
             <a:pPr algn="l">
+              <a:buNone/>
               <a:defRPr sz="1725" b="1">
                 <a:solidFill>
                   <a:srgbClr val="0B1F3A"/>
@@ -3965,7 +3999,7 @@
                   <a:srgbClr val="0B1F3A"/>
                 </a:solidFill>
               </a:rPr>
-              <a:t>30분 후속 미팅에서 첫 진단 범위를 잡을 것인가</a:t>
+              <a:t>30분 후속 미팅에서 첫 진단 범위를 협의할 것인가</a:t>
             </a:r>
           </a:p>
         </p:txBody>
@@ -4036,6 +4070,7 @@
           <a:lstStyle xmlns:a="http://schemas.openxmlformats.org/drawingml/2006/main"/>
           <a:p xmlns:a="http://schemas.openxmlformats.org/drawingml/2006/main">
             <a:pPr algn="ctr">
+              <a:buNone/>
               <a:defRPr sz="1725" b="1">
                 <a:solidFill>
                   <a:srgbClr val="FFFFFF"/>
@@ -4048,7 +4083,7 @@
                   <a:srgbClr val="FFFFFF"/>
                 </a:solidFill>
               </a:rPr>
-              <a:t>PoC 계약이 아니라, 90일 실행 프로그램을 검토할 30분 후속 미팅입니다.</a:t>
+              <a:t>PoC 계약 요청이 아니라, 90일 실행 프로그램을 검토할 30분 후속 미팅입니다.</a:t>
             </a:r>
           </a:p>
         </p:txBody>
@@ -4115,6 +4150,7 @@
           <a:lstStyle xmlns:a="http://schemas.openxmlformats.org/drawingml/2006/main"/>
           <a:p xmlns:a="http://schemas.openxmlformats.org/drawingml/2006/main">
             <a:pPr algn="l">
+              <a:buNone/>
               <a:defRPr sz="1500" b="1">
                 <a:solidFill>
                   <a:srgbClr val="FFC400"/>
@@ -4165,6 +4201,7 @@
           <a:lstStyle xmlns:a="http://schemas.openxmlformats.org/drawingml/2006/main"/>
           <a:p xmlns:a="http://schemas.openxmlformats.org/drawingml/2006/main">
             <a:pPr algn="l">
+              <a:buNone/>
               <a:defRPr sz="3600" b="1">
                 <a:solidFill>
                   <a:srgbClr val="FFFFFF"/>
@@ -4182,6 +4219,7 @@
           </a:p>
           <a:p xmlns:a="http://schemas.openxmlformats.org/drawingml/2006/main">
             <a:pPr algn="l">
+              <a:buNone/>
               <a:defRPr sz="3600" b="1">
                 <a:solidFill>
                   <a:srgbClr val="FFFFFF"/>
@@ -4199,6 +4237,7 @@
           </a:p>
           <a:p xmlns:a="http://schemas.openxmlformats.org/drawingml/2006/main">
             <a:pPr algn="l">
+              <a:buNone/>
               <a:defRPr sz="3600" b="1">
                 <a:solidFill>
                   <a:srgbClr val="FFFFFF"/>
@@ -4211,7 +4250,7 @@
                   <a:srgbClr val="FFFFFF"/>
                 </a:solidFill>
               </a:rPr>
-              <a:t>찍는 것이 아닙니다.</a:t>
+              <a:t>고르는 것이 아닙니다.</a:t>
             </a:r>
           </a:p>
         </p:txBody>
@@ -4280,6 +4319,7 @@
           <a:lstStyle xmlns:a="http://schemas.openxmlformats.org/drawingml/2006/main"/>
           <a:p xmlns:a="http://schemas.openxmlformats.org/drawingml/2006/main">
             <a:pPr algn="l">
+              <a:buNone/>
               <a:defRPr sz="2025" b="1">
                 <a:solidFill>
                   <a:srgbClr val="FFFFFF"/>
@@ -4297,6 +4337,7 @@
           </a:p>
           <a:p xmlns:a="http://schemas.openxmlformats.org/drawingml/2006/main">
             <a:pPr algn="l">
+              <a:buNone/>
               <a:defRPr sz="2025" b="1">
                 <a:solidFill>
                   <a:srgbClr val="FFFFFF"/>
@@ -4380,6 +4421,7 @@
           <a:lstStyle xmlns:a="http://schemas.openxmlformats.org/drawingml/2006/main"/>
           <a:p xmlns:a="http://schemas.openxmlformats.org/drawingml/2006/main">
             <a:pPr algn="l">
+              <a:buNone/>
               <a:defRPr sz="1725" b="1">
                 <a:solidFill>
                   <a:srgbClr val="FFFFFF"/>
@@ -4430,6 +4472,7 @@
           <a:lstStyle xmlns:a="http://schemas.openxmlformats.org/drawingml/2006/main"/>
           <a:p xmlns:a="http://schemas.openxmlformats.org/drawingml/2006/main">
             <a:pPr algn="r">
+              <a:buNone/>
               <a:defRPr sz="1500" b="1">
                 <a:solidFill>
                   <a:srgbClr val="FFFFFF"/>
@@ -4509,6 +4552,7 @@
           <a:lstStyle xmlns:a="http://schemas.openxmlformats.org/drawingml/2006/main"/>
           <a:p xmlns:a="http://schemas.openxmlformats.org/drawingml/2006/main">
             <a:pPr algn="l">
+              <a:buNone/>
               <a:defRPr sz="1050" b="1">
                 <a:solidFill>
                   <a:srgbClr val="2F80ED"/>
@@ -4559,6 +4603,7 @@
           <a:lstStyle xmlns:a="http://schemas.openxmlformats.org/drawingml/2006/main"/>
           <a:p xmlns:a="http://schemas.openxmlformats.org/drawingml/2006/main">
             <a:pPr algn="l">
+              <a:buNone/>
               <a:defRPr sz="2850" b="1">
                 <a:solidFill>
                   <a:srgbClr val="0B1F3A"/>
@@ -4571,7 +4616,7 @@
                   <a:srgbClr val="0B1F3A"/>
                 </a:solidFill>
               </a:rPr>
-              <a:t>마지막 제안은 PoC 3개가 아닙니다</a:t>
+              <a:t>후속 제안의 핵심은 PoC 3개가 아닙니다</a:t>
             </a:r>
           </a:p>
         </p:txBody>
@@ -4640,6 +4685,7 @@
           <a:lstStyle xmlns:a="http://schemas.openxmlformats.org/drawingml/2006/main"/>
           <a:p xmlns:a="http://schemas.openxmlformats.org/drawingml/2006/main">
             <a:pPr algn="r">
+              <a:buNone/>
               <a:defRPr sz="1350" b="1">
                 <a:solidFill>
                   <a:srgbClr val="2F80ED"/>
@@ -4690,6 +4736,7 @@
           <a:lstStyle xmlns:a="http://schemas.openxmlformats.org/drawingml/2006/main"/>
           <a:p xmlns:a="http://schemas.openxmlformats.org/drawingml/2006/main">
             <a:pPr algn="r">
+              <a:buNone/>
               <a:defRPr sz="1200" b="1">
                 <a:solidFill>
                   <a:srgbClr val="0B1F3A"/>
@@ -4771,6 +4818,7 @@
           <a:lstStyle xmlns:a="http://schemas.openxmlformats.org/drawingml/2006/main"/>
           <a:p xmlns:a="http://schemas.openxmlformats.org/drawingml/2006/main">
             <a:pPr algn="l">
+              <a:buNone/>
               <a:defRPr sz="975" b="0">
                 <a:solidFill>
                   <a:srgbClr val="5C6B7A"/>
@@ -4887,6 +4935,7 @@
           <a:lstStyle xmlns:a="http://schemas.openxmlformats.org/drawingml/2006/main"/>
           <a:p xmlns:a="http://schemas.openxmlformats.org/drawingml/2006/main">
             <a:pPr algn="l">
+              <a:buNone/>
               <a:defRPr sz="1725" b="1">
                 <a:solidFill>
                   <a:srgbClr val="0B1F3A"/>
@@ -4899,7 +4948,7 @@
                   <a:srgbClr val="0B1F3A"/>
                 </a:solidFill>
               </a:rPr>
-              <a:t>약한 제안</a:t>
+              <a:t>단편 제안</a:t>
             </a:r>
           </a:p>
         </p:txBody>
@@ -4937,6 +4986,7 @@
           <a:lstStyle xmlns:a="http://schemas.openxmlformats.org/drawingml/2006/main"/>
           <a:p xmlns:a="http://schemas.openxmlformats.org/drawingml/2006/main">
             <a:pPr algn="l">
+              <a:buNone/>
               <a:defRPr sz="1575" b="0">
                 <a:solidFill>
                   <a:srgbClr val="5C6B7A"/>
@@ -4949,11 +4999,12 @@
                   <a:srgbClr val="5C6B7A"/>
                 </a:solidFill>
               </a:rPr>
-              <a:t>• IC Copilot 합시다</a:t>
+              <a:t>• IC Copilot 단품 제안</a:t>
             </a:r>
           </a:p>
           <a:p xmlns:a="http://schemas.openxmlformats.org/drawingml/2006/main">
             <a:pPr algn="l">
+              <a:buNone/>
               <a:defRPr sz="1575" b="0">
                 <a:solidFill>
                   <a:srgbClr val="5C6B7A"/>
@@ -4966,11 +5017,12 @@
                   <a:srgbClr val="5C6B7A"/>
                 </a:solidFill>
               </a:rPr>
-              <a:t>• Portfolio Radar 합시다</a:t>
+              <a:t>• Portfolio Radar 단품 제안</a:t>
             </a:r>
           </a:p>
           <a:p xmlns:a="http://schemas.openxmlformats.org/drawingml/2006/main">
             <a:pPr algn="l">
+              <a:buNone/>
               <a:defRPr sz="1575" b="0">
                 <a:solidFill>
                   <a:srgbClr val="5C6B7A"/>
@@ -4983,7 +5035,7 @@
                   <a:srgbClr val="5C6B7A"/>
                 </a:solidFill>
               </a:rPr>
-              <a:t>• Global BD Agent 합시다</a:t>
+              <a:t>• Global BD Agent 단품 제안</a:t>
             </a:r>
           </a:p>
           <a:p xmlns:a="http://schemas.openxmlformats.org/drawingml/2006/main">
@@ -4993,6 +5045,7 @@
           </a:p>
           <a:p xmlns:a="http://schemas.openxmlformats.org/drawingml/2006/main">
             <a:pPr algn="l">
+              <a:buNone/>
               <a:defRPr sz="1575" b="0">
                 <a:solidFill>
                   <a:srgbClr val="5C6B7A"/>
@@ -5005,11 +5058,12 @@
                   <a:srgbClr val="5C6B7A"/>
                 </a:solidFill>
               </a:rPr>
-              <a:t>상대 반응:</a:t>
+              <a:t>예상 질문:</a:t>
             </a:r>
           </a:p>
           <a:p xmlns:a="http://schemas.openxmlformats.org/drawingml/2006/main">
             <a:pPr algn="l">
+              <a:buNone/>
               <a:defRPr sz="1575" b="0">
                 <a:solidFill>
                   <a:srgbClr val="5C6B7A"/>
@@ -5022,11 +5076,12 @@
                   <a:srgbClr val="5C6B7A"/>
                 </a:solidFill>
               </a:rPr>
-              <a:t>“SI 제안인가?”</a:t>
+              <a:t>“외주 구축 제안인가?”</a:t>
             </a:r>
           </a:p>
           <a:p xmlns:a="http://schemas.openxmlformats.org/drawingml/2006/main">
             <a:pPr algn="l">
+              <a:buNone/>
               <a:defRPr sz="1575" b="0">
                 <a:solidFill>
                   <a:srgbClr val="5C6B7A"/>
@@ -5039,11 +5094,12 @@
                   <a:srgbClr val="5C6B7A"/>
                 </a:solidFill>
               </a:rPr>
-              <a:t>“우리가 왜 지금 해야 하지?”</a:t>
+              <a:t>“왜 지금 해야 하지?”</a:t>
             </a:r>
           </a:p>
           <a:p xmlns:a="http://schemas.openxmlformats.org/drawingml/2006/main">
             <a:pPr algn="l">
+              <a:buNone/>
               <a:defRPr sz="1575" b="0">
                 <a:solidFill>
                   <a:srgbClr val="5C6B7A"/>
@@ -5160,6 +5216,7 @@
           <a:lstStyle xmlns:a="http://schemas.openxmlformats.org/drawingml/2006/main"/>
           <a:p xmlns:a="http://schemas.openxmlformats.org/drawingml/2006/main">
             <a:pPr algn="l">
+              <a:buNone/>
               <a:defRPr sz="1725" b="1">
                 <a:solidFill>
                   <a:srgbClr val="0B1F3A"/>
@@ -5172,7 +5229,7 @@
                   <a:srgbClr val="0B1F3A"/>
                 </a:solidFill>
               </a:rPr>
-              <a:t>강한 제안</a:t>
+              <a:t>실행 제안</a:t>
             </a:r>
           </a:p>
         </p:txBody>
@@ -5210,6 +5267,7 @@
           <a:lstStyle xmlns:a="http://schemas.openxmlformats.org/drawingml/2006/main"/>
           <a:p xmlns:a="http://schemas.openxmlformats.org/drawingml/2006/main">
             <a:pPr algn="l">
+              <a:buNone/>
               <a:defRPr sz="1575" b="0">
                 <a:solidFill>
                   <a:srgbClr val="5C6B7A"/>
@@ -5227,6 +5285,7 @@
           </a:p>
           <a:p xmlns:a="http://schemas.openxmlformats.org/drawingml/2006/main">
             <a:pPr algn="l">
+              <a:buNone/>
               <a:defRPr sz="1575" b="0">
                 <a:solidFill>
                   <a:srgbClr val="5C6B7A"/>
@@ -5244,6 +5303,7 @@
           </a:p>
           <a:p xmlns:a="http://schemas.openxmlformats.org/drawingml/2006/main">
             <a:pPr algn="l">
+              <a:buNone/>
               <a:defRPr sz="1575" b="0">
                 <a:solidFill>
                   <a:srgbClr val="5C6B7A"/>
@@ -5261,6 +5321,7 @@
           </a:p>
           <a:p xmlns:a="http://schemas.openxmlformats.org/drawingml/2006/main">
             <a:pPr algn="l">
+              <a:buNone/>
               <a:defRPr sz="1575" b="0">
                 <a:solidFill>
                   <a:srgbClr val="5C6B7A"/>
@@ -5273,11 +5334,12 @@
                   <a:srgbClr val="5C6B7A"/>
                 </a:solidFill>
               </a:rPr>
-              <a:t>• 90일 안에 작동 산출물 확보</a:t>
+              <a:t>• 90일 안에 검증 산출물 확보</a:t>
             </a:r>
           </a:p>
           <a:p xmlns:a="http://schemas.openxmlformats.org/drawingml/2006/main">
             <a:pPr algn="l">
+              <a:buNone/>
               <a:defRPr sz="1575" b="0">
                 <a:solidFill>
                   <a:srgbClr val="5C6B7A"/>
@@ -5328,6 +5390,7 @@
           <a:lstStyle xmlns:a="http://schemas.openxmlformats.org/drawingml/2006/main"/>
           <a:p xmlns:a="http://schemas.openxmlformats.org/drawingml/2006/main">
             <a:pPr algn="ctr">
+              <a:buNone/>
               <a:defRPr sz="1875" b="1">
                 <a:solidFill>
                   <a:srgbClr val="0B1F3A"/>
@@ -5340,7 +5403,7 @@
                   <a:srgbClr val="0B1F3A"/>
                 </a:solidFill>
               </a:rPr>
-              <a:t>핵심은 시스템 납품이 아니라 내부 실행 역량과 실증 산출물을 같이 만드는 것입니다.</a:t>
+              <a:t>핵심은 시스템 납품이 아니라 내부 실행 역량과 검증 산출물을 같이 만드는 것입니다.</a:t>
             </a:r>
           </a:p>
         </p:txBody>
@@ -5407,6 +5470,7 @@
           <a:lstStyle xmlns:a="http://schemas.openxmlformats.org/drawingml/2006/main"/>
           <a:p xmlns:a="http://schemas.openxmlformats.org/drawingml/2006/main">
             <a:pPr algn="l">
+              <a:buNone/>
               <a:defRPr sz="1050" b="1">
                 <a:solidFill>
                   <a:srgbClr val="2F80ED"/>
@@ -5457,6 +5521,7 @@
           <a:lstStyle xmlns:a="http://schemas.openxmlformats.org/drawingml/2006/main"/>
           <a:p xmlns:a="http://schemas.openxmlformats.org/drawingml/2006/main">
             <a:pPr algn="l">
+              <a:buNone/>
               <a:defRPr sz="2850" b="1">
                 <a:solidFill>
                   <a:srgbClr val="0B1F3A"/>
@@ -5538,6 +5603,7 @@
           <a:lstStyle xmlns:a="http://schemas.openxmlformats.org/drawingml/2006/main"/>
           <a:p xmlns:a="http://schemas.openxmlformats.org/drawingml/2006/main">
             <a:pPr algn="r">
+              <a:buNone/>
               <a:defRPr sz="1350" b="1">
                 <a:solidFill>
                   <a:srgbClr val="2F80ED"/>
@@ -5588,6 +5654,7 @@
           <a:lstStyle xmlns:a="http://schemas.openxmlformats.org/drawingml/2006/main"/>
           <a:p xmlns:a="http://schemas.openxmlformats.org/drawingml/2006/main">
             <a:pPr algn="r">
+              <a:buNone/>
               <a:defRPr sz="1200" b="1">
                 <a:solidFill>
                   <a:srgbClr val="0B1F3A"/>
@@ -5669,6 +5736,7 @@
           <a:lstStyle xmlns:a="http://schemas.openxmlformats.org/drawingml/2006/main"/>
           <a:p xmlns:a="http://schemas.openxmlformats.org/drawingml/2006/main">
             <a:pPr algn="l">
+              <a:buNone/>
               <a:defRPr sz="975" b="0">
                 <a:solidFill>
                   <a:srgbClr val="5C6B7A"/>
@@ -5785,6 +5853,7 @@
           <a:lstStyle xmlns:a="http://schemas.openxmlformats.org/drawingml/2006/main"/>
           <a:p xmlns:a="http://schemas.openxmlformats.org/drawingml/2006/main">
             <a:pPr algn="ctr">
+              <a:buNone/>
               <a:defRPr sz="1950" b="1">
                 <a:solidFill>
                   <a:srgbClr val="2F80ED"/>
@@ -5835,6 +5904,7 @@
           <a:lstStyle xmlns:a="http://schemas.openxmlformats.org/drawingml/2006/main"/>
           <a:p xmlns:a="http://schemas.openxmlformats.org/drawingml/2006/main">
             <a:pPr algn="l">
+              <a:buNone/>
               <a:defRPr sz="2250" b="1">
                 <a:solidFill>
                   <a:srgbClr val="0B1F3A"/>
@@ -5885,6 +5955,7 @@
           <a:lstStyle xmlns:a="http://schemas.openxmlformats.org/drawingml/2006/main"/>
           <a:p xmlns:a="http://schemas.openxmlformats.org/drawingml/2006/main">
             <a:pPr algn="l">
+              <a:buNone/>
               <a:defRPr sz="1425" b="0">
                 <a:solidFill>
                   <a:srgbClr val="5C6B7A"/>
@@ -6001,6 +6072,7 @@
           <a:lstStyle xmlns:a="http://schemas.openxmlformats.org/drawingml/2006/main"/>
           <a:p xmlns:a="http://schemas.openxmlformats.org/drawingml/2006/main">
             <a:pPr algn="ctr">
+              <a:buNone/>
               <a:defRPr sz="1950" b="1">
                 <a:solidFill>
                   <a:srgbClr val="2F80ED"/>
@@ -6051,6 +6123,7 @@
           <a:lstStyle xmlns:a="http://schemas.openxmlformats.org/drawingml/2006/main"/>
           <a:p xmlns:a="http://schemas.openxmlformats.org/drawingml/2006/main">
             <a:pPr algn="l">
+              <a:buNone/>
               <a:defRPr sz="2250" b="1">
                 <a:solidFill>
                   <a:srgbClr val="0B1F3A"/>
@@ -6101,6 +6174,7 @@
           <a:lstStyle xmlns:a="http://schemas.openxmlformats.org/drawingml/2006/main"/>
           <a:p xmlns:a="http://schemas.openxmlformats.org/drawingml/2006/main">
             <a:pPr algn="l">
+              <a:buNone/>
               <a:defRPr sz="1425" b="0">
                 <a:solidFill>
                   <a:srgbClr val="5C6B7A"/>
@@ -6217,6 +6291,7 @@
           <a:lstStyle xmlns:a="http://schemas.openxmlformats.org/drawingml/2006/main"/>
           <a:p xmlns:a="http://schemas.openxmlformats.org/drawingml/2006/main">
             <a:pPr algn="ctr">
+              <a:buNone/>
               <a:defRPr sz="1950" b="1">
                 <a:solidFill>
                   <a:srgbClr val="2F80ED"/>
@@ -6267,6 +6342,7 @@
           <a:lstStyle xmlns:a="http://schemas.openxmlformats.org/drawingml/2006/main"/>
           <a:p xmlns:a="http://schemas.openxmlformats.org/drawingml/2006/main">
             <a:pPr algn="l">
+              <a:buNone/>
               <a:defRPr sz="2250" b="1">
                 <a:solidFill>
                   <a:srgbClr val="0B1F3A"/>
@@ -6317,6 +6393,7 @@
           <a:lstStyle xmlns:a="http://schemas.openxmlformats.org/drawingml/2006/main"/>
           <a:p xmlns:a="http://schemas.openxmlformats.org/drawingml/2006/main">
             <a:pPr algn="l">
+              <a:buNone/>
               <a:defRPr sz="1425" b="0">
                 <a:solidFill>
                   <a:srgbClr val="5C6B7A"/>
@@ -6367,6 +6444,7 @@
           <a:lstStyle xmlns:a="http://schemas.openxmlformats.org/drawingml/2006/main"/>
           <a:p xmlns:a="http://schemas.openxmlformats.org/drawingml/2006/main">
             <a:pPr algn="ctr">
+              <a:buNone/>
               <a:defRPr sz="1875" b="1">
                 <a:solidFill>
                   <a:srgbClr val="0E58C8"/>
@@ -6446,6 +6524,7 @@
           <a:lstStyle xmlns:a="http://schemas.openxmlformats.org/drawingml/2006/main"/>
           <a:p xmlns:a="http://schemas.openxmlformats.org/drawingml/2006/main">
             <a:pPr algn="l">
+              <a:buNone/>
               <a:defRPr sz="1050" b="1">
                 <a:solidFill>
                   <a:srgbClr val="2F80ED"/>
@@ -6496,6 +6575,7 @@
           <a:lstStyle xmlns:a="http://schemas.openxmlformats.org/drawingml/2006/main"/>
           <a:p xmlns:a="http://schemas.openxmlformats.org/drawingml/2006/main">
             <a:pPr algn="l">
+              <a:buNone/>
               <a:defRPr sz="2850" b="1">
                 <a:solidFill>
                   <a:srgbClr val="0B1F3A"/>
@@ -6577,6 +6657,7 @@
           <a:lstStyle xmlns:a="http://schemas.openxmlformats.org/drawingml/2006/main"/>
           <a:p xmlns:a="http://schemas.openxmlformats.org/drawingml/2006/main">
             <a:pPr algn="r">
+              <a:buNone/>
               <a:defRPr sz="1350" b="1">
                 <a:solidFill>
                   <a:srgbClr val="2F80ED"/>
@@ -6627,6 +6708,7 @@
           <a:lstStyle xmlns:a="http://schemas.openxmlformats.org/drawingml/2006/main"/>
           <a:p xmlns:a="http://schemas.openxmlformats.org/drawingml/2006/main">
             <a:pPr algn="r">
+              <a:buNone/>
               <a:defRPr sz="1200" b="1">
                 <a:solidFill>
                   <a:srgbClr val="0B1F3A"/>
@@ -6708,6 +6790,7 @@
           <a:lstStyle xmlns:a="http://schemas.openxmlformats.org/drawingml/2006/main"/>
           <a:p xmlns:a="http://schemas.openxmlformats.org/drawingml/2006/main">
             <a:pPr algn="l">
+              <a:buNone/>
               <a:defRPr sz="975" b="0">
                 <a:solidFill>
                   <a:srgbClr val="5C6B7A"/>
@@ -6793,6 +6876,7 @@
           <a:lstStyle xmlns:a="http://schemas.openxmlformats.org/drawingml/2006/main"/>
           <a:p xmlns:a="http://schemas.openxmlformats.org/drawingml/2006/main">
             <a:pPr algn="ctr">
+              <a:buNone/>
               <a:defRPr sz="1725" b="1">
                 <a:solidFill>
                   <a:srgbClr val="0B1F3A"/>
@@ -6843,6 +6927,7 @@
           <a:lstStyle xmlns:a="http://schemas.openxmlformats.org/drawingml/2006/main"/>
           <a:p xmlns:a="http://schemas.openxmlformats.org/drawingml/2006/main">
             <a:pPr algn="ctr">
+              <a:buNone/>
               <a:defRPr sz="1275" b="1">
                 <a:solidFill>
                   <a:srgbClr val="2F80ED"/>
@@ -6893,6 +6978,7 @@
           <a:lstStyle xmlns:a="http://schemas.openxmlformats.org/drawingml/2006/main"/>
           <a:p xmlns:a="http://schemas.openxmlformats.org/drawingml/2006/main">
             <a:pPr algn="ctr">
+              <a:buNone/>
               <a:defRPr sz="2250" b="1">
                 <a:solidFill>
                   <a:srgbClr val="2F80ED"/>
@@ -6978,6 +7064,7 @@
           <a:lstStyle xmlns:a="http://schemas.openxmlformats.org/drawingml/2006/main"/>
           <a:p xmlns:a="http://schemas.openxmlformats.org/drawingml/2006/main">
             <a:pPr algn="ctr">
+              <a:buNone/>
               <a:defRPr sz="1725" b="1">
                 <a:solidFill>
                   <a:srgbClr val="0B1F3A"/>
@@ -6995,6 +7082,7 @@
           </a:p>
           <a:p xmlns:a="http://schemas.openxmlformats.org/drawingml/2006/main">
             <a:pPr algn="ctr">
+              <a:buNone/>
               <a:defRPr sz="1725" b="1">
                 <a:solidFill>
                   <a:srgbClr val="0B1F3A"/>
@@ -7045,6 +7133,7 @@
           <a:lstStyle xmlns:a="http://schemas.openxmlformats.org/drawingml/2006/main"/>
           <a:p xmlns:a="http://schemas.openxmlformats.org/drawingml/2006/main">
             <a:pPr algn="ctr">
+              <a:buNone/>
               <a:defRPr sz="1275" b="1">
                 <a:solidFill>
                   <a:srgbClr val="2F80ED"/>
@@ -7095,6 +7184,7 @@
           <a:lstStyle xmlns:a="http://schemas.openxmlformats.org/drawingml/2006/main"/>
           <a:p xmlns:a="http://schemas.openxmlformats.org/drawingml/2006/main">
             <a:pPr algn="ctr">
+              <a:buNone/>
               <a:defRPr sz="2250" b="1">
                 <a:solidFill>
                   <a:srgbClr val="2F80ED"/>
@@ -7178,6 +7268,7 @@
           <a:lstStyle xmlns:a="http://schemas.openxmlformats.org/drawingml/2006/main"/>
           <a:p xmlns:a="http://schemas.openxmlformats.org/drawingml/2006/main">
             <a:pPr algn="ctr">
+              <a:buNone/>
               <a:defRPr sz="1725" b="1">
                 <a:solidFill>
                   <a:srgbClr val="FFFFFF"/>
@@ -7195,6 +7286,7 @@
           </a:p>
           <a:p xmlns:a="http://schemas.openxmlformats.org/drawingml/2006/main">
             <a:pPr algn="ctr">
+              <a:buNone/>
               <a:defRPr sz="1725" b="1">
                 <a:solidFill>
                   <a:srgbClr val="FFFFFF"/>
@@ -7245,6 +7337,7 @@
           <a:lstStyle xmlns:a="http://schemas.openxmlformats.org/drawingml/2006/main"/>
           <a:p xmlns:a="http://schemas.openxmlformats.org/drawingml/2006/main">
             <a:pPr algn="ctr">
+              <a:buNone/>
               <a:defRPr sz="1275" b="1">
                 <a:solidFill>
                   <a:srgbClr val="FFC400"/>
@@ -7295,6 +7388,7 @@
           <a:lstStyle xmlns:a="http://schemas.openxmlformats.org/drawingml/2006/main"/>
           <a:p xmlns:a="http://schemas.openxmlformats.org/drawingml/2006/main">
             <a:pPr algn="ctr">
+              <a:buNone/>
               <a:defRPr sz="2250" b="1">
                 <a:solidFill>
                   <a:srgbClr val="2F80ED"/>
@@ -7380,6 +7474,7 @@
           <a:lstStyle xmlns:a="http://schemas.openxmlformats.org/drawingml/2006/main"/>
           <a:p xmlns:a="http://schemas.openxmlformats.org/drawingml/2006/main">
             <a:pPr algn="ctr">
+              <a:buNone/>
               <a:defRPr sz="1725" b="1">
                 <a:solidFill>
                   <a:srgbClr val="0B1F3A"/>
@@ -7397,6 +7492,7 @@
           </a:p>
           <a:p xmlns:a="http://schemas.openxmlformats.org/drawingml/2006/main">
             <a:pPr algn="ctr">
+              <a:buNone/>
               <a:defRPr sz="1725" b="1">
                 <a:solidFill>
                   <a:srgbClr val="0B1F3A"/>
@@ -7447,6 +7543,7 @@
           <a:lstStyle xmlns:a="http://schemas.openxmlformats.org/drawingml/2006/main"/>
           <a:p xmlns:a="http://schemas.openxmlformats.org/drawingml/2006/main">
             <a:pPr algn="ctr">
+              <a:buNone/>
               <a:defRPr sz="1275" b="1">
                 <a:solidFill>
                   <a:srgbClr val="2F80ED"/>
@@ -7497,6 +7594,7 @@
           <a:lstStyle xmlns:a="http://schemas.openxmlformats.org/drawingml/2006/main"/>
           <a:p xmlns:a="http://schemas.openxmlformats.org/drawingml/2006/main">
             <a:pPr algn="ctr">
+              <a:buNone/>
               <a:defRPr sz="2250" b="1">
                 <a:solidFill>
                   <a:srgbClr val="2F80ED"/>
@@ -7582,6 +7680,7 @@
           <a:lstStyle xmlns:a="http://schemas.openxmlformats.org/drawingml/2006/main"/>
           <a:p xmlns:a="http://schemas.openxmlformats.org/drawingml/2006/main">
             <a:pPr algn="ctr">
+              <a:buNone/>
               <a:defRPr sz="1725" b="1">
                 <a:solidFill>
                   <a:srgbClr val="0B1F3A"/>
@@ -7599,6 +7698,7 @@
           </a:p>
           <a:p xmlns:a="http://schemas.openxmlformats.org/drawingml/2006/main">
             <a:pPr algn="ctr">
+              <a:buNone/>
               <a:defRPr sz="1725" b="1">
                 <a:solidFill>
                   <a:srgbClr val="0B1F3A"/>
@@ -7649,6 +7749,7 @@
           <a:lstStyle xmlns:a="http://schemas.openxmlformats.org/drawingml/2006/main"/>
           <a:p xmlns:a="http://schemas.openxmlformats.org/drawingml/2006/main">
             <a:pPr algn="ctr">
+              <a:buNone/>
               <a:defRPr sz="1275" b="1">
                 <a:solidFill>
                   <a:srgbClr val="2F80ED"/>
@@ -7699,6 +7800,7 @@
           <a:lstStyle xmlns:a="http://schemas.openxmlformats.org/drawingml/2006/main"/>
           <a:p xmlns:a="http://schemas.openxmlformats.org/drawingml/2006/main">
             <a:pPr algn="ctr">
+              <a:buNone/>
               <a:defRPr sz="1875" b="1">
                 <a:solidFill>
                   <a:srgbClr val="0B1F3A"/>
@@ -7711,7 +7813,7 @@
                   <a:srgbClr val="0B1F3A"/>
                 </a:solidFill>
               </a:rPr>
-              <a:t>단순 교육도, 외부 SI 구축도 아닙니다. 내부 업무를 가장 잘 아는 사람과 함께 작동 산출물을 만드는 방식입니다.</a:t>
+              <a:t>단순 교육도, 외부 SI 구축도 아닙니다. 내부 업무를 아는 사람과 함께 검증 가능한 산출물을 만드는 방식입니다.</a:t>
             </a:r>
           </a:p>
         </p:txBody>
@@ -7778,6 +7880,7 @@
           <a:lstStyle xmlns:a="http://schemas.openxmlformats.org/drawingml/2006/main"/>
           <a:p xmlns:a="http://schemas.openxmlformats.org/drawingml/2006/main">
             <a:pPr algn="l">
+              <a:buNone/>
               <a:defRPr sz="1050" b="1">
                 <a:solidFill>
                   <a:srgbClr val="2F80ED"/>
@@ -7828,6 +7931,7 @@
           <a:lstStyle xmlns:a="http://schemas.openxmlformats.org/drawingml/2006/main"/>
           <a:p xmlns:a="http://schemas.openxmlformats.org/drawingml/2006/main">
             <a:pPr algn="l">
+              <a:buNone/>
               <a:defRPr sz="2850" b="1">
                 <a:solidFill>
                   <a:srgbClr val="0B1F3A"/>
@@ -7909,6 +8013,7 @@
           <a:lstStyle xmlns:a="http://schemas.openxmlformats.org/drawingml/2006/main"/>
           <a:p xmlns:a="http://schemas.openxmlformats.org/drawingml/2006/main">
             <a:pPr algn="r">
+              <a:buNone/>
               <a:defRPr sz="1350" b="1">
                 <a:solidFill>
                   <a:srgbClr val="2F80ED"/>
@@ -7959,6 +8064,7 @@
           <a:lstStyle xmlns:a="http://schemas.openxmlformats.org/drawingml/2006/main"/>
           <a:p xmlns:a="http://schemas.openxmlformats.org/drawingml/2006/main">
             <a:pPr algn="r">
+              <a:buNone/>
               <a:defRPr sz="1200" b="1">
                 <a:solidFill>
                   <a:srgbClr val="0B1F3A"/>
@@ -8040,6 +8146,7 @@
           <a:lstStyle xmlns:a="http://schemas.openxmlformats.org/drawingml/2006/main"/>
           <a:p xmlns:a="http://schemas.openxmlformats.org/drawingml/2006/main">
             <a:pPr algn="l">
+              <a:buNone/>
               <a:defRPr sz="975" b="0">
                 <a:solidFill>
                   <a:srgbClr val="5C6B7A"/>
@@ -8158,6 +8265,7 @@
           <a:lstStyle xmlns:a="http://schemas.openxmlformats.org/drawingml/2006/main"/>
           <a:p xmlns:a="http://schemas.openxmlformats.org/drawingml/2006/main">
             <a:pPr algn="ctr">
+              <a:buNone/>
               <a:defRPr sz="1125" b="1">
                 <a:solidFill>
                   <a:srgbClr val="FFFFFF"/>
@@ -8208,6 +8316,7 @@
           <a:lstStyle xmlns:a="http://schemas.openxmlformats.org/drawingml/2006/main"/>
           <a:p xmlns:a="http://schemas.openxmlformats.org/drawingml/2006/main">
             <a:pPr algn="l">
+              <a:buNone/>
               <a:defRPr sz="1800" b="1">
                 <a:solidFill>
                   <a:srgbClr val="0B1F3A"/>
@@ -8258,6 +8367,7 @@
           <a:lstStyle xmlns:a="http://schemas.openxmlformats.org/drawingml/2006/main"/>
           <a:p xmlns:a="http://schemas.openxmlformats.org/drawingml/2006/main">
             <a:pPr algn="l">
+              <a:buNone/>
               <a:defRPr sz="1575" b="0">
                 <a:solidFill>
                   <a:srgbClr val="5C6B7A"/>
@@ -8275,6 +8385,7 @@
           </a:p>
           <a:p xmlns:a="http://schemas.openxmlformats.org/drawingml/2006/main">
             <a:pPr algn="l">
+              <a:buNone/>
               <a:defRPr sz="1575" b="0">
                 <a:solidFill>
                   <a:srgbClr val="5C6B7A"/>
@@ -8393,6 +8504,7 @@
           <a:lstStyle xmlns:a="http://schemas.openxmlformats.org/drawingml/2006/main"/>
           <a:p xmlns:a="http://schemas.openxmlformats.org/drawingml/2006/main">
             <a:pPr algn="ctr">
+              <a:buNone/>
               <a:defRPr sz="1125" b="1">
                 <a:solidFill>
                   <a:srgbClr val="FFFFFF"/>
@@ -8443,6 +8555,7 @@
           <a:lstStyle xmlns:a="http://schemas.openxmlformats.org/drawingml/2006/main"/>
           <a:p xmlns:a="http://schemas.openxmlformats.org/drawingml/2006/main">
             <a:pPr algn="l">
+              <a:buNone/>
               <a:defRPr sz="1800" b="1">
                 <a:solidFill>
                   <a:srgbClr val="0B1F3A"/>
@@ -8493,6 +8606,7 @@
           <a:lstStyle xmlns:a="http://schemas.openxmlformats.org/drawingml/2006/main"/>
           <a:p xmlns:a="http://schemas.openxmlformats.org/drawingml/2006/main">
             <a:pPr algn="l">
+              <a:buNone/>
               <a:defRPr sz="1575" b="0">
                 <a:solidFill>
                   <a:srgbClr val="5C6B7A"/>
@@ -8510,6 +8624,7 @@
           </a:p>
           <a:p xmlns:a="http://schemas.openxmlformats.org/drawingml/2006/main">
             <a:pPr algn="l">
+              <a:buNone/>
               <a:defRPr sz="1575" b="0">
                 <a:solidFill>
                   <a:srgbClr val="5C6B7A"/>
@@ -8628,6 +8743,7 @@
           <a:lstStyle xmlns:a="http://schemas.openxmlformats.org/drawingml/2006/main"/>
           <a:p xmlns:a="http://schemas.openxmlformats.org/drawingml/2006/main">
             <a:pPr algn="ctr">
+              <a:buNone/>
               <a:defRPr sz="1125" b="1">
                 <a:solidFill>
                   <a:srgbClr val="FFFFFF"/>
@@ -8678,6 +8794,7 @@
           <a:lstStyle xmlns:a="http://schemas.openxmlformats.org/drawingml/2006/main"/>
           <a:p xmlns:a="http://schemas.openxmlformats.org/drawingml/2006/main">
             <a:pPr algn="l">
+              <a:buNone/>
               <a:defRPr sz="1800" b="1">
                 <a:solidFill>
                   <a:srgbClr val="0B1F3A"/>
@@ -8728,6 +8845,7 @@
           <a:lstStyle xmlns:a="http://schemas.openxmlformats.org/drawingml/2006/main"/>
           <a:p xmlns:a="http://schemas.openxmlformats.org/drawingml/2006/main">
             <a:pPr algn="l">
+              <a:buNone/>
               <a:defRPr sz="1575" b="0">
                 <a:solidFill>
                   <a:srgbClr val="5C6B7A"/>
@@ -8745,6 +8863,7 @@
           </a:p>
           <a:p xmlns:a="http://schemas.openxmlformats.org/drawingml/2006/main">
             <a:pPr algn="l">
+              <a:buNone/>
               <a:defRPr sz="1575" b="0">
                 <a:solidFill>
                   <a:srgbClr val="5C6B7A"/>
@@ -8861,6 +8980,7 @@
           <a:lstStyle xmlns:a="http://schemas.openxmlformats.org/drawingml/2006/main"/>
           <a:p xmlns:a="http://schemas.openxmlformats.org/drawingml/2006/main">
             <a:pPr algn="ctr">
+              <a:buNone/>
               <a:defRPr sz="1125" b="1">
                 <a:solidFill>
                   <a:srgbClr val="FFFFFF"/>
@@ -8911,6 +9031,7 @@
           <a:lstStyle xmlns:a="http://schemas.openxmlformats.org/drawingml/2006/main"/>
           <a:p xmlns:a="http://schemas.openxmlformats.org/drawingml/2006/main">
             <a:pPr algn="l">
+              <a:buNone/>
               <a:defRPr sz="1800" b="1">
                 <a:solidFill>
                   <a:srgbClr val="FFFFFF"/>
@@ -8961,6 +9082,7 @@
           <a:lstStyle xmlns:a="http://schemas.openxmlformats.org/drawingml/2006/main"/>
           <a:p xmlns:a="http://schemas.openxmlformats.org/drawingml/2006/main">
             <a:pPr algn="l">
+              <a:buNone/>
               <a:defRPr sz="1575" b="0">
                 <a:solidFill>
                   <a:srgbClr val="FFFFFF"/>
@@ -8978,6 +9100,7 @@
           </a:p>
           <a:p xmlns:a="http://schemas.openxmlformats.org/drawingml/2006/main">
             <a:pPr algn="l">
+              <a:buNone/>
               <a:defRPr sz="1575" b="0">
                 <a:solidFill>
                   <a:srgbClr val="FFFFFF"/>
@@ -9028,6 +9151,7 @@
           <a:lstStyle xmlns:a="http://schemas.openxmlformats.org/drawingml/2006/main"/>
           <a:p xmlns:a="http://schemas.openxmlformats.org/drawingml/2006/main">
             <a:pPr algn="ctr">
+              <a:buNone/>
               <a:defRPr sz="2025" b="1">
                 <a:solidFill>
                   <a:srgbClr val="0E58C8"/>
@@ -9107,6 +9231,7 @@
           <a:lstStyle xmlns:a="http://schemas.openxmlformats.org/drawingml/2006/main"/>
           <a:p xmlns:a="http://schemas.openxmlformats.org/drawingml/2006/main">
             <a:pPr algn="l">
+              <a:buNone/>
               <a:defRPr sz="1050" b="1">
                 <a:solidFill>
                   <a:srgbClr val="2F80ED"/>
@@ -9157,6 +9282,7 @@
           <a:lstStyle xmlns:a="http://schemas.openxmlformats.org/drawingml/2006/main"/>
           <a:p xmlns:a="http://schemas.openxmlformats.org/drawingml/2006/main">
             <a:pPr algn="l">
+              <a:buNone/>
               <a:defRPr sz="2850" b="1">
                 <a:solidFill>
                   <a:srgbClr val="0B1F3A"/>
@@ -9238,6 +9364,7 @@
           <a:lstStyle xmlns:a="http://schemas.openxmlformats.org/drawingml/2006/main"/>
           <a:p xmlns:a="http://schemas.openxmlformats.org/drawingml/2006/main">
             <a:pPr algn="r">
+              <a:buNone/>
               <a:defRPr sz="1350" b="1">
                 <a:solidFill>
                   <a:srgbClr val="2F80ED"/>
@@ -9288,6 +9415,7 @@
           <a:lstStyle xmlns:a="http://schemas.openxmlformats.org/drawingml/2006/main"/>
           <a:p xmlns:a="http://schemas.openxmlformats.org/drawingml/2006/main">
             <a:pPr algn="r">
+              <a:buNone/>
               <a:defRPr sz="1200" b="1">
                 <a:solidFill>
                   <a:srgbClr val="0B1F3A"/>
@@ -9369,6 +9497,7 @@
           <a:lstStyle xmlns:a="http://schemas.openxmlformats.org/drawingml/2006/main"/>
           <a:p xmlns:a="http://schemas.openxmlformats.org/drawingml/2006/main">
             <a:pPr algn="l">
+              <a:buNone/>
               <a:defRPr sz="975" b="0">
                 <a:solidFill>
                   <a:srgbClr val="5C6B7A"/>
@@ -9454,6 +9583,7 @@
           <a:lstStyle xmlns:a="http://schemas.openxmlformats.org/drawingml/2006/main"/>
           <a:p xmlns:a="http://schemas.openxmlformats.org/drawingml/2006/main">
             <a:pPr algn="l">
+              <a:buNone/>
               <a:defRPr sz="1350" b="1">
                 <a:solidFill>
                   <a:srgbClr val="2F80ED"/>
@@ -9504,6 +9634,7 @@
           <a:lstStyle xmlns:a="http://schemas.openxmlformats.org/drawingml/2006/main"/>
           <a:p xmlns:a="http://schemas.openxmlformats.org/drawingml/2006/main">
             <a:pPr algn="l">
+              <a:buNone/>
               <a:defRPr sz="1350" b="1">
                 <a:solidFill>
                   <a:srgbClr val="2F80ED"/>
@@ -9554,6 +9685,7 @@
           <a:lstStyle xmlns:a="http://schemas.openxmlformats.org/drawingml/2006/main"/>
           <a:p xmlns:a="http://schemas.openxmlformats.org/drawingml/2006/main">
             <a:pPr algn="l">
+              <a:buNone/>
               <a:defRPr sz="1350" b="1">
                 <a:solidFill>
                   <a:srgbClr val="2F80ED"/>
@@ -9604,6 +9736,7 @@
           <a:lstStyle xmlns:a="http://schemas.openxmlformats.org/drawingml/2006/main"/>
           <a:p xmlns:a="http://schemas.openxmlformats.org/drawingml/2006/main">
             <a:pPr algn="l">
+              <a:buNone/>
               <a:defRPr sz="1350" b="1">
                 <a:solidFill>
                   <a:srgbClr val="2F80ED"/>
@@ -9716,6 +9849,7 @@
           <a:lstStyle xmlns:a="http://schemas.openxmlformats.org/drawingml/2006/main"/>
           <a:p xmlns:a="http://schemas.openxmlformats.org/drawingml/2006/main">
             <a:pPr algn="ctr">
+              <a:buNone/>
               <a:defRPr sz="1125" b="1">
                 <a:solidFill>
                   <a:srgbClr val="2F80ED"/>
@@ -9766,6 +9900,7 @@
           <a:lstStyle xmlns:a="http://schemas.openxmlformats.org/drawingml/2006/main"/>
           <a:p xmlns:a="http://schemas.openxmlformats.org/drawingml/2006/main">
             <a:pPr algn="l">
+              <a:buNone/>
               <a:defRPr sz="1425" b="1">
                 <a:solidFill>
                   <a:srgbClr val="0B1F3A"/>
@@ -9816,6 +9951,7 @@
           <a:lstStyle xmlns:a="http://schemas.openxmlformats.org/drawingml/2006/main"/>
           <a:p xmlns:a="http://schemas.openxmlformats.org/drawingml/2006/main">
             <a:pPr algn="l">
+              <a:buNone/>
               <a:defRPr sz="1275" b="0">
                 <a:solidFill>
                   <a:srgbClr val="5C6B7A"/>
@@ -9866,6 +10002,7 @@
           <a:lstStyle xmlns:a="http://schemas.openxmlformats.org/drawingml/2006/main"/>
           <a:p xmlns:a="http://schemas.openxmlformats.org/drawingml/2006/main">
             <a:pPr algn="l">
+              <a:buNone/>
               <a:defRPr sz="1275" b="0">
                 <a:solidFill>
                   <a:srgbClr val="0B1F3A"/>
@@ -9978,6 +10115,7 @@
           <a:lstStyle xmlns:a="http://schemas.openxmlformats.org/drawingml/2006/main"/>
           <a:p xmlns:a="http://schemas.openxmlformats.org/drawingml/2006/main">
             <a:pPr algn="ctr">
+              <a:buNone/>
               <a:defRPr sz="1125" b="1">
                 <a:solidFill>
                   <a:srgbClr val="2F80ED"/>
@@ -10028,6 +10166,7 @@
           <a:lstStyle xmlns:a="http://schemas.openxmlformats.org/drawingml/2006/main"/>
           <a:p xmlns:a="http://schemas.openxmlformats.org/drawingml/2006/main">
             <a:pPr algn="l">
+              <a:buNone/>
               <a:defRPr sz="1425" b="1">
                 <a:solidFill>
                   <a:srgbClr val="0B1F3A"/>
@@ -10078,6 +10217,7 @@
           <a:lstStyle xmlns:a="http://schemas.openxmlformats.org/drawingml/2006/main"/>
           <a:p xmlns:a="http://schemas.openxmlformats.org/drawingml/2006/main">
             <a:pPr algn="l">
+              <a:buNone/>
               <a:defRPr sz="1275" b="0">
                 <a:solidFill>
                   <a:srgbClr val="5C6B7A"/>
@@ -10090,7 +10230,7 @@
                   <a:srgbClr val="5C6B7A"/>
                 </a:solidFill>
               </a:rPr>
-              <a:t>SV 업무 중 어디가 먼저 ROI가 나는가</a:t>
+              <a:t>SV 업무 중 어디서 ROI가 먼저 확인되는가</a:t>
             </a:r>
           </a:p>
         </p:txBody>
@@ -10128,6 +10268,7 @@
           <a:lstStyle xmlns:a="http://schemas.openxmlformats.org/drawingml/2006/main"/>
           <a:p xmlns:a="http://schemas.openxmlformats.org/drawingml/2006/main">
             <a:pPr algn="l">
+              <a:buNone/>
               <a:defRPr sz="1275" b="0">
                 <a:solidFill>
                   <a:srgbClr val="0B1F3A"/>
@@ -10240,6 +10381,7 @@
           <a:lstStyle xmlns:a="http://schemas.openxmlformats.org/drawingml/2006/main"/>
           <a:p xmlns:a="http://schemas.openxmlformats.org/drawingml/2006/main">
             <a:pPr algn="ctr">
+              <a:buNone/>
               <a:defRPr sz="1125" b="1">
                 <a:solidFill>
                   <a:srgbClr val="FFFFFF"/>
@@ -10290,6 +10432,7 @@
           <a:lstStyle xmlns:a="http://schemas.openxmlformats.org/drawingml/2006/main"/>
           <a:p xmlns:a="http://schemas.openxmlformats.org/drawingml/2006/main">
             <a:pPr algn="l">
+              <a:buNone/>
               <a:defRPr sz="1425" b="1">
                 <a:solidFill>
                   <a:srgbClr val="0B1F3A"/>
@@ -10340,6 +10483,7 @@
           <a:lstStyle xmlns:a="http://schemas.openxmlformats.org/drawingml/2006/main"/>
           <a:p xmlns:a="http://schemas.openxmlformats.org/drawingml/2006/main">
             <a:pPr algn="l">
+              <a:buNone/>
               <a:defRPr sz="1275" b="0">
                 <a:solidFill>
                   <a:srgbClr val="5C6B7A"/>
@@ -10390,6 +10534,7 @@
           <a:lstStyle xmlns:a="http://schemas.openxmlformats.org/drawingml/2006/main"/>
           <a:p xmlns:a="http://schemas.openxmlformats.org/drawingml/2006/main">
             <a:pPr algn="l">
+              <a:buNone/>
               <a:defRPr sz="1275" b="0">
                 <a:solidFill>
                   <a:srgbClr val="0B1F3A"/>
@@ -10502,6 +10647,7 @@
           <a:lstStyle xmlns:a="http://schemas.openxmlformats.org/drawingml/2006/main"/>
           <a:p xmlns:a="http://schemas.openxmlformats.org/drawingml/2006/main">
             <a:pPr algn="ctr">
+              <a:buNone/>
               <a:defRPr sz="1125" b="1">
                 <a:solidFill>
                   <a:srgbClr val="2F80ED"/>
@@ -10552,6 +10698,7 @@
           <a:lstStyle xmlns:a="http://schemas.openxmlformats.org/drawingml/2006/main"/>
           <a:p xmlns:a="http://schemas.openxmlformats.org/drawingml/2006/main">
             <a:pPr algn="l">
+              <a:buNone/>
               <a:defRPr sz="1425" b="1">
                 <a:solidFill>
                   <a:srgbClr val="0B1F3A"/>
@@ -10602,6 +10749,7 @@
           <a:lstStyle xmlns:a="http://schemas.openxmlformats.org/drawingml/2006/main"/>
           <a:p xmlns:a="http://schemas.openxmlformats.org/drawingml/2006/main">
             <a:pPr algn="l">
+              <a:buNone/>
               <a:defRPr sz="1275" b="0">
                 <a:solidFill>
                   <a:srgbClr val="5C6B7A"/>
@@ -10652,6 +10800,7 @@
           <a:lstStyle xmlns:a="http://schemas.openxmlformats.org/drawingml/2006/main"/>
           <a:p xmlns:a="http://schemas.openxmlformats.org/drawingml/2006/main">
             <a:pPr algn="l">
+              <a:buNone/>
               <a:defRPr sz="1275" b="0">
                 <a:solidFill>
                   <a:srgbClr val="0B1F3A"/>
@@ -10664,7 +10813,7 @@
                   <a:srgbClr val="0B1F3A"/>
                 </a:solidFill>
               </a:rPr>
-              <a:t>작동 PoC / 테스트 로그</a:t>
+              <a:t>검증용 PoC / 테스트 로그</a:t>
             </a:r>
           </a:p>
         </p:txBody>
@@ -10764,6 +10913,7 @@
           <a:lstStyle xmlns:a="http://schemas.openxmlformats.org/drawingml/2006/main"/>
           <a:p xmlns:a="http://schemas.openxmlformats.org/drawingml/2006/main">
             <a:pPr algn="ctr">
+              <a:buNone/>
               <a:defRPr sz="1125" b="1">
                 <a:solidFill>
                   <a:srgbClr val="2F80ED"/>
@@ -10814,6 +10964,7 @@
           <a:lstStyle xmlns:a="http://schemas.openxmlformats.org/drawingml/2006/main"/>
           <a:p xmlns:a="http://schemas.openxmlformats.org/drawingml/2006/main">
             <a:pPr algn="l">
+              <a:buNone/>
               <a:defRPr sz="1425" b="1">
                 <a:solidFill>
                   <a:srgbClr val="0B1F3A"/>
@@ -10864,6 +11015,7 @@
           <a:lstStyle xmlns:a="http://schemas.openxmlformats.org/drawingml/2006/main"/>
           <a:p xmlns:a="http://schemas.openxmlformats.org/drawingml/2006/main">
             <a:pPr algn="l">
+              <a:buNone/>
               <a:defRPr sz="1275" b="0">
                 <a:solidFill>
                   <a:srgbClr val="5C6B7A"/>
@@ -10914,6 +11066,7 @@
           <a:lstStyle xmlns:a="http://schemas.openxmlformats.org/drawingml/2006/main"/>
           <a:p xmlns:a="http://schemas.openxmlformats.org/drawingml/2006/main">
             <a:pPr algn="l">
+              <a:buNone/>
               <a:defRPr sz="1275" b="0">
                 <a:solidFill>
                   <a:srgbClr val="0B1F3A"/>
@@ -10993,6 +11146,7 @@
           <a:lstStyle xmlns:a="http://schemas.openxmlformats.org/drawingml/2006/main"/>
           <a:p xmlns:a="http://schemas.openxmlformats.org/drawingml/2006/main">
             <a:pPr algn="l">
+              <a:buNone/>
               <a:defRPr sz="1050" b="1">
                 <a:solidFill>
                   <a:srgbClr val="2F80ED"/>
@@ -11043,6 +11197,7 @@
           <a:lstStyle xmlns:a="http://schemas.openxmlformats.org/drawingml/2006/main"/>
           <a:p xmlns:a="http://schemas.openxmlformats.org/drawingml/2006/main">
             <a:pPr algn="l">
+              <a:buNone/>
               <a:defRPr sz="2850" b="1">
                 <a:solidFill>
                   <a:srgbClr val="0B1F3A"/>
@@ -11124,6 +11279,7 @@
           <a:lstStyle xmlns:a="http://schemas.openxmlformats.org/drawingml/2006/main"/>
           <a:p xmlns:a="http://schemas.openxmlformats.org/drawingml/2006/main">
             <a:pPr algn="r">
+              <a:buNone/>
               <a:defRPr sz="1350" b="1">
                 <a:solidFill>
                   <a:srgbClr val="2F80ED"/>
@@ -11174,6 +11330,7 @@
           <a:lstStyle xmlns:a="http://schemas.openxmlformats.org/drawingml/2006/main"/>
           <a:p xmlns:a="http://schemas.openxmlformats.org/drawingml/2006/main">
             <a:pPr algn="r">
+              <a:buNone/>
               <a:defRPr sz="1200" b="1">
                 <a:solidFill>
                   <a:srgbClr val="0B1F3A"/>
@@ -11255,6 +11412,7 @@
           <a:lstStyle xmlns:a="http://schemas.openxmlformats.org/drawingml/2006/main"/>
           <a:p xmlns:a="http://schemas.openxmlformats.org/drawingml/2006/main">
             <a:pPr algn="l">
+              <a:buNone/>
               <a:defRPr sz="975" b="0">
                 <a:solidFill>
                   <a:srgbClr val="5C6B7A"/>
@@ -11340,6 +11498,7 @@
           <a:lstStyle xmlns:a="http://schemas.openxmlformats.org/drawingml/2006/main"/>
           <a:p xmlns:a="http://schemas.openxmlformats.org/drawingml/2006/main">
             <a:pPr algn="l">
+              <a:buNone/>
               <a:defRPr sz="1800" b="1">
                 <a:solidFill>
                   <a:srgbClr val="0B1F3A"/>
@@ -11390,6 +11549,7 @@
           <a:lstStyle xmlns:a="http://schemas.openxmlformats.org/drawingml/2006/main"/>
           <a:p xmlns:a="http://schemas.openxmlformats.org/drawingml/2006/main">
             <a:pPr algn="l">
+              <a:buNone/>
               <a:defRPr sz="1350" b="0">
                 <a:solidFill>
                   <a:srgbClr val="5C6B7A"/>
@@ -11440,6 +11600,7 @@
           <a:lstStyle xmlns:a="http://schemas.openxmlformats.org/drawingml/2006/main"/>
           <a:p xmlns:a="http://schemas.openxmlformats.org/drawingml/2006/main">
             <a:pPr algn="l">
+              <a:buNone/>
               <a:defRPr sz="1350" b="0">
                 <a:solidFill>
                   <a:srgbClr val="5C6B7A"/>
@@ -11457,6 +11618,7 @@
           </a:p>
           <a:p xmlns:a="http://schemas.openxmlformats.org/drawingml/2006/main">
             <a:pPr algn="l">
+              <a:buNone/>
               <a:defRPr sz="1350" b="0">
                 <a:solidFill>
                   <a:srgbClr val="5C6B7A"/>
@@ -11573,6 +11735,7 @@
           <a:lstStyle xmlns:a="http://schemas.openxmlformats.org/drawingml/2006/main"/>
           <a:p xmlns:a="http://schemas.openxmlformats.org/drawingml/2006/main">
             <a:pPr algn="l">
+              <a:buNone/>
               <a:defRPr sz="1800" b="1">
                 <a:solidFill>
                   <a:srgbClr val="0B1F3A"/>
@@ -11590,6 +11753,7 @@
           </a:p>
           <a:p xmlns:a="http://schemas.openxmlformats.org/drawingml/2006/main">
             <a:pPr algn="l">
+              <a:buNone/>
               <a:defRPr sz="1800" b="1">
                 <a:solidFill>
                   <a:srgbClr val="0B1F3A"/>
@@ -11640,6 +11804,7 @@
           <a:lstStyle xmlns:a="http://schemas.openxmlformats.org/drawingml/2006/main"/>
           <a:p xmlns:a="http://schemas.openxmlformats.org/drawingml/2006/main">
             <a:pPr algn="l">
+              <a:buNone/>
               <a:defRPr sz="1350" b="0">
                 <a:solidFill>
                   <a:srgbClr val="5C6B7A"/>
@@ -11690,6 +11855,7 @@
           <a:lstStyle xmlns:a="http://schemas.openxmlformats.org/drawingml/2006/main"/>
           <a:p xmlns:a="http://schemas.openxmlformats.org/drawingml/2006/main">
             <a:pPr algn="l">
+              <a:buNone/>
               <a:defRPr sz="1350" b="0">
                 <a:solidFill>
                   <a:srgbClr val="5C6B7A"/>
@@ -11702,11 +11868,12 @@
                   <a:srgbClr val="5C6B7A"/>
                 </a:solidFill>
               </a:rPr>
-              <a:t>심사역/스텝</a:t>
+              <a:t>심사역/스태프</a:t>
             </a:r>
           </a:p>
           <a:p xmlns:a="http://schemas.openxmlformats.org/drawingml/2006/main">
             <a:pPr algn="l">
+              <a:buNone/>
               <a:defRPr sz="1350" b="0">
                 <a:solidFill>
                   <a:srgbClr val="5C6B7A"/>
@@ -11792,6 +11959,7 @@
           <a:lstStyle xmlns:a="http://schemas.openxmlformats.org/drawingml/2006/main"/>
           <a:p xmlns:a="http://schemas.openxmlformats.org/drawingml/2006/main">
             <a:pPr algn="l">
+              <a:buNone/>
               <a:defRPr sz="1800" b="1">
                 <a:solidFill>
                   <a:srgbClr val="0B1F3A"/>
@@ -11809,6 +11977,7 @@
           </a:p>
           <a:p xmlns:a="http://schemas.openxmlformats.org/drawingml/2006/main">
             <a:pPr algn="l">
+              <a:buNone/>
               <a:defRPr sz="1800" b="1">
                 <a:solidFill>
                   <a:srgbClr val="0B1F3A"/>
@@ -11859,6 +12028,7 @@
           <a:lstStyle xmlns:a="http://schemas.openxmlformats.org/drawingml/2006/main"/>
           <a:p xmlns:a="http://schemas.openxmlformats.org/drawingml/2006/main">
             <a:pPr algn="l">
+              <a:buNone/>
               <a:defRPr sz="1350" b="0">
                 <a:solidFill>
                   <a:srgbClr val="5C6B7A"/>
@@ -11909,6 +12079,7 @@
           <a:lstStyle xmlns:a="http://schemas.openxmlformats.org/drawingml/2006/main"/>
           <a:p xmlns:a="http://schemas.openxmlformats.org/drawingml/2006/main">
             <a:pPr algn="l">
+              <a:buNone/>
               <a:defRPr sz="1350" b="0">
                 <a:solidFill>
                   <a:srgbClr val="5C6B7A"/>
@@ -11926,6 +12097,7 @@
           </a:p>
           <a:p xmlns:a="http://schemas.openxmlformats.org/drawingml/2006/main">
             <a:pPr algn="l">
+              <a:buNone/>
               <a:defRPr sz="1350" b="0">
                 <a:solidFill>
                   <a:srgbClr val="5C6B7A"/>
@@ -12011,6 +12183,7 @@
           <a:lstStyle xmlns:a="http://schemas.openxmlformats.org/drawingml/2006/main"/>
           <a:p xmlns:a="http://schemas.openxmlformats.org/drawingml/2006/main">
             <a:pPr algn="l">
+              <a:buNone/>
               <a:defRPr sz="1800" b="1">
                 <a:solidFill>
                   <a:srgbClr val="0B1F3A"/>
@@ -12028,6 +12201,7 @@
           </a:p>
           <a:p xmlns:a="http://schemas.openxmlformats.org/drawingml/2006/main">
             <a:pPr algn="l">
+              <a:buNone/>
               <a:defRPr sz="1800" b="1">
                 <a:solidFill>
                   <a:srgbClr val="0B1F3A"/>
@@ -12078,6 +12252,7 @@
           <a:lstStyle xmlns:a="http://schemas.openxmlformats.org/drawingml/2006/main"/>
           <a:p xmlns:a="http://schemas.openxmlformats.org/drawingml/2006/main">
             <a:pPr algn="l">
+              <a:buNone/>
               <a:defRPr sz="1350" b="0">
                 <a:solidFill>
                   <a:srgbClr val="5C6B7A"/>
@@ -12128,6 +12303,7 @@
           <a:lstStyle xmlns:a="http://schemas.openxmlformats.org/drawingml/2006/main"/>
           <a:p xmlns:a="http://schemas.openxmlformats.org/drawingml/2006/main">
             <a:pPr algn="l">
+              <a:buNone/>
               <a:defRPr sz="1350" b="0">
                 <a:solidFill>
                   <a:srgbClr val="5C6B7A"/>
@@ -12145,6 +12321,7 @@
           </a:p>
           <a:p xmlns:a="http://schemas.openxmlformats.org/drawingml/2006/main">
             <a:pPr algn="l">
+              <a:buNone/>
               <a:defRPr sz="1350" b="0">
                 <a:solidFill>
                   <a:srgbClr val="5C6B7A"/>
@@ -12195,6 +12372,7 @@
           <a:lstStyle xmlns:a="http://schemas.openxmlformats.org/drawingml/2006/main"/>
           <a:p xmlns:a="http://schemas.openxmlformats.org/drawingml/2006/main">
             <a:pPr algn="ctr">
+              <a:buNone/>
               <a:defRPr sz="1800" b="1">
                 <a:solidFill>
                   <a:srgbClr val="0B1F3A"/>
@@ -12274,6 +12452,7 @@
           <a:lstStyle xmlns:a="http://schemas.openxmlformats.org/drawingml/2006/main"/>
           <a:p xmlns:a="http://schemas.openxmlformats.org/drawingml/2006/main">
             <a:pPr algn="l">
+              <a:buNone/>
               <a:defRPr sz="1050" b="1">
                 <a:solidFill>
                   <a:srgbClr val="2F80ED"/>
@@ -12324,6 +12503,7 @@
           <a:lstStyle xmlns:a="http://schemas.openxmlformats.org/drawingml/2006/main"/>
           <a:p xmlns:a="http://schemas.openxmlformats.org/drawingml/2006/main">
             <a:pPr algn="l">
+              <a:buNone/>
               <a:defRPr sz="2850" b="1">
                 <a:solidFill>
                   <a:srgbClr val="0B1F3A"/>
@@ -12405,6 +12585,7 @@
           <a:lstStyle xmlns:a="http://schemas.openxmlformats.org/drawingml/2006/main"/>
           <a:p xmlns:a="http://schemas.openxmlformats.org/drawingml/2006/main">
             <a:pPr algn="r">
+              <a:buNone/>
               <a:defRPr sz="1350" b="1">
                 <a:solidFill>
                   <a:srgbClr val="2F80ED"/>
@@ -12455,6 +12636,7 @@
           <a:lstStyle xmlns:a="http://schemas.openxmlformats.org/drawingml/2006/main"/>
           <a:p xmlns:a="http://schemas.openxmlformats.org/drawingml/2006/main">
             <a:pPr algn="r">
+              <a:buNone/>
               <a:defRPr sz="1200" b="1">
                 <a:solidFill>
                   <a:srgbClr val="0B1F3A"/>
@@ -12536,6 +12718,7 @@
           <a:lstStyle xmlns:a="http://schemas.openxmlformats.org/drawingml/2006/main"/>
           <a:p xmlns:a="http://schemas.openxmlformats.org/drawingml/2006/main">
             <a:pPr algn="l">
+              <a:buNone/>
               <a:defRPr sz="975" b="0">
                 <a:solidFill>
                   <a:srgbClr val="5C6B7A"/>
@@ -12652,6 +12835,7 @@
           <a:lstStyle xmlns:a="http://schemas.openxmlformats.org/drawingml/2006/main"/>
           <a:p xmlns:a="http://schemas.openxmlformats.org/drawingml/2006/main">
             <a:pPr algn="ctr">
+              <a:buNone/>
               <a:defRPr sz="975" b="1">
                 <a:solidFill>
                   <a:srgbClr val="FFFFFF"/>
@@ -12702,6 +12886,7 @@
           <a:lstStyle xmlns:a="http://schemas.openxmlformats.org/drawingml/2006/main"/>
           <a:p xmlns:a="http://schemas.openxmlformats.org/drawingml/2006/main">
             <a:pPr algn="l">
+              <a:buNone/>
               <a:defRPr sz="1725" b="1">
                 <a:solidFill>
                   <a:srgbClr val="0B1F3A"/>
@@ -12818,6 +13003,7 @@
           <a:lstStyle xmlns:a="http://schemas.openxmlformats.org/drawingml/2006/main"/>
           <a:p xmlns:a="http://schemas.openxmlformats.org/drawingml/2006/main">
             <a:pPr algn="ctr">
+              <a:buNone/>
               <a:defRPr sz="975" b="1">
                 <a:solidFill>
                   <a:srgbClr val="FFFFFF"/>
@@ -12868,6 +13054,7 @@
           <a:lstStyle xmlns:a="http://schemas.openxmlformats.org/drawingml/2006/main"/>
           <a:p xmlns:a="http://schemas.openxmlformats.org/drawingml/2006/main">
             <a:pPr algn="l">
+              <a:buNone/>
               <a:defRPr sz="1725" b="1">
                 <a:solidFill>
                   <a:srgbClr val="0B1F3A"/>
@@ -12984,6 +13171,7 @@
           <a:lstStyle xmlns:a="http://schemas.openxmlformats.org/drawingml/2006/main"/>
           <a:p xmlns:a="http://schemas.openxmlformats.org/drawingml/2006/main">
             <a:pPr algn="ctr">
+              <a:buNone/>
               <a:defRPr sz="975" b="1">
                 <a:solidFill>
                   <a:srgbClr val="FFFFFF"/>
@@ -13034,6 +13222,7 @@
           <a:lstStyle xmlns:a="http://schemas.openxmlformats.org/drawingml/2006/main"/>
           <a:p xmlns:a="http://schemas.openxmlformats.org/drawingml/2006/main">
             <a:pPr algn="l">
+              <a:buNone/>
               <a:defRPr sz="1725" b="1">
                 <a:solidFill>
                   <a:srgbClr val="0B1F3A"/>
@@ -13150,6 +13339,7 @@
           <a:lstStyle xmlns:a="http://schemas.openxmlformats.org/drawingml/2006/main"/>
           <a:p xmlns:a="http://schemas.openxmlformats.org/drawingml/2006/main">
             <a:pPr algn="ctr">
+              <a:buNone/>
               <a:defRPr sz="975" b="1">
                 <a:solidFill>
                   <a:srgbClr val="FFFFFF"/>
@@ -13200,6 +13390,7 @@
           <a:lstStyle xmlns:a="http://schemas.openxmlformats.org/drawingml/2006/main"/>
           <a:p xmlns:a="http://schemas.openxmlformats.org/drawingml/2006/main">
             <a:pPr algn="l">
+              <a:buNone/>
               <a:defRPr sz="1725" b="1">
                 <a:solidFill>
                   <a:srgbClr val="0B1F3A"/>
@@ -13316,6 +13507,7 @@
           <a:lstStyle xmlns:a="http://schemas.openxmlformats.org/drawingml/2006/main"/>
           <a:p xmlns:a="http://schemas.openxmlformats.org/drawingml/2006/main">
             <a:pPr algn="ctr">
+              <a:buNone/>
               <a:defRPr sz="975" b="1">
                 <a:solidFill>
                   <a:srgbClr val="FFFFFF"/>
@@ -13366,6 +13558,7 @@
           <a:lstStyle xmlns:a="http://schemas.openxmlformats.org/drawingml/2006/main"/>
           <a:p xmlns:a="http://schemas.openxmlformats.org/drawingml/2006/main">
             <a:pPr algn="l">
+              <a:buNone/>
               <a:defRPr sz="1725" b="1">
                 <a:solidFill>
                   <a:srgbClr val="0B1F3A"/>
@@ -13378,7 +13571,7 @@
                   <a:srgbClr val="0B1F3A"/>
                 </a:solidFill>
               </a:rPr>
-              <a:t>외부 파트너와 PoC 범위 정의</a:t>
+              <a:t>외부 파트너와 PoC 검증 범위 정의</a:t>
             </a:r>
           </a:p>
         </p:txBody>
@@ -13416,6 +13609,7 @@
           <a:lstStyle xmlns:a="http://schemas.openxmlformats.org/drawingml/2006/main"/>
           <a:p xmlns:a="http://schemas.openxmlformats.org/drawingml/2006/main">
             <a:pPr algn="ctr">
+              <a:buNone/>
               <a:defRPr sz="1800" b="1">
                 <a:solidFill>
                   <a:srgbClr val="0E58C8"/>
@@ -13495,6 +13689,7 @@
           <a:lstStyle xmlns:a="http://schemas.openxmlformats.org/drawingml/2006/main"/>
           <a:p xmlns:a="http://schemas.openxmlformats.org/drawingml/2006/main">
             <a:pPr algn="l">
+              <a:buNone/>
               <a:defRPr sz="1050" b="1">
                 <a:solidFill>
                   <a:srgbClr val="2F80ED"/>
@@ -13545,6 +13740,7 @@
           <a:lstStyle xmlns:a="http://schemas.openxmlformats.org/drawingml/2006/main"/>
           <a:p xmlns:a="http://schemas.openxmlformats.org/drawingml/2006/main">
             <a:pPr algn="l">
+              <a:buNone/>
               <a:defRPr sz="2850" b="1">
                 <a:solidFill>
                   <a:srgbClr val="0B1F3A"/>
@@ -13626,6 +13822,7 @@
           <a:lstStyle xmlns:a="http://schemas.openxmlformats.org/drawingml/2006/main"/>
           <a:p xmlns:a="http://schemas.openxmlformats.org/drawingml/2006/main">
             <a:pPr algn="r">
+              <a:buNone/>
               <a:defRPr sz="1350" b="1">
                 <a:solidFill>
                   <a:srgbClr val="2F80ED"/>
@@ -13676,6 +13873,7 @@
           <a:lstStyle xmlns:a="http://schemas.openxmlformats.org/drawingml/2006/main"/>
           <a:p xmlns:a="http://schemas.openxmlformats.org/drawingml/2006/main">
             <a:pPr algn="r">
+              <a:buNone/>
               <a:defRPr sz="1200" b="1">
                 <a:solidFill>
                   <a:srgbClr val="0B1F3A"/>
@@ -13757,6 +13955,7 @@
           <a:lstStyle xmlns:a="http://schemas.openxmlformats.org/drawingml/2006/main"/>
           <a:p xmlns:a="http://schemas.openxmlformats.org/drawingml/2006/main">
             <a:pPr algn="l">
+              <a:buNone/>
               <a:defRPr sz="975" b="0">
                 <a:solidFill>
                   <a:srgbClr val="5C6B7A"/>
@@ -13873,6 +14072,7 @@
           <a:lstStyle xmlns:a="http://schemas.openxmlformats.org/drawingml/2006/main"/>
           <a:p xmlns:a="http://schemas.openxmlformats.org/drawingml/2006/main">
             <a:pPr algn="l">
+              <a:buNone/>
               <a:defRPr sz="1725" b="1">
                 <a:solidFill>
                   <a:srgbClr val="0B1F3A"/>
@@ -13923,6 +14123,7 @@
           <a:lstStyle xmlns:a="http://schemas.openxmlformats.org/drawingml/2006/main"/>
           <a:p xmlns:a="http://schemas.openxmlformats.org/drawingml/2006/main">
             <a:pPr algn="l">
+              <a:buNone/>
               <a:defRPr sz="1200" b="1">
                 <a:solidFill>
                   <a:srgbClr val="5C6B7A"/>
@@ -13973,6 +14174,7 @@
           <a:lstStyle xmlns:a="http://schemas.openxmlformats.org/drawingml/2006/main"/>
           <a:p xmlns:a="http://schemas.openxmlformats.org/drawingml/2006/main">
             <a:pPr algn="l">
+              <a:buNone/>
               <a:defRPr sz="1200" b="0">
                 <a:solidFill>
                   <a:srgbClr val="5C6B7A"/>
@@ -14023,6 +14225,7 @@
           <a:lstStyle xmlns:a="http://schemas.openxmlformats.org/drawingml/2006/main"/>
           <a:p xmlns:a="http://schemas.openxmlformats.org/drawingml/2006/main">
             <a:pPr algn="l">
+              <a:buNone/>
               <a:defRPr sz="1200" b="1">
                 <a:solidFill>
                   <a:srgbClr val="5C6B7A"/>
@@ -14073,6 +14276,7 @@
           <a:lstStyle xmlns:a="http://schemas.openxmlformats.org/drawingml/2006/main"/>
           <a:p xmlns:a="http://schemas.openxmlformats.org/drawingml/2006/main">
             <a:pPr algn="l">
+              <a:buNone/>
               <a:defRPr sz="1200" b="0">
                 <a:solidFill>
                   <a:srgbClr val="0B1F3A"/>
@@ -14090,6 +14294,7 @@
           </a:p>
           <a:p xmlns:a="http://schemas.openxmlformats.org/drawingml/2006/main">
             <a:pPr algn="l">
+              <a:buNone/>
               <a:defRPr sz="1200" b="0">
                 <a:solidFill>
                   <a:srgbClr val="0B1F3A"/>
@@ -14206,6 +14411,7 @@
           <a:lstStyle xmlns:a="http://schemas.openxmlformats.org/drawingml/2006/main"/>
           <a:p xmlns:a="http://schemas.openxmlformats.org/drawingml/2006/main">
             <a:pPr algn="l">
+              <a:buNone/>
               <a:defRPr sz="1725" b="1">
                 <a:solidFill>
                   <a:srgbClr val="0B1F3A"/>
@@ -14256,6 +14462,7 @@
           <a:lstStyle xmlns:a="http://schemas.openxmlformats.org/drawingml/2006/main"/>
           <a:p xmlns:a="http://schemas.openxmlformats.org/drawingml/2006/main">
             <a:pPr algn="l">
+              <a:buNone/>
               <a:defRPr sz="1200" b="1">
                 <a:solidFill>
                   <a:srgbClr val="5C6B7A"/>
@@ -14306,6 +14513,7 @@
           <a:lstStyle xmlns:a="http://schemas.openxmlformats.org/drawingml/2006/main"/>
           <a:p xmlns:a="http://schemas.openxmlformats.org/drawingml/2006/main">
             <a:pPr algn="l">
+              <a:buNone/>
               <a:defRPr sz="1200" b="0">
                 <a:solidFill>
                   <a:srgbClr val="5C6B7A"/>
@@ -14318,7 +14526,7 @@
                   <a:srgbClr val="5C6B7A"/>
                 </a:solidFill>
               </a:rPr>
-              <a:t>본부 차원의 포트폴리오 value-up 모델이 우선일 때</a:t>
+              <a:t>본부 차원의 포트폴리오 Value-up 모델이 우선일 때</a:t>
             </a:r>
           </a:p>
         </p:txBody>
@@ -14356,6 +14564,7 @@
           <a:lstStyle xmlns:a="http://schemas.openxmlformats.org/drawingml/2006/main"/>
           <a:p xmlns:a="http://schemas.openxmlformats.org/drawingml/2006/main">
             <a:pPr algn="l">
+              <a:buNone/>
               <a:defRPr sz="1200" b="1">
                 <a:solidFill>
                   <a:srgbClr val="5C6B7A"/>
@@ -14406,6 +14615,7 @@
           <a:lstStyle xmlns:a="http://schemas.openxmlformats.org/drawingml/2006/main"/>
           <a:p xmlns:a="http://schemas.openxmlformats.org/drawingml/2006/main">
             <a:pPr algn="l">
+              <a:buNone/>
               <a:defRPr sz="1200" b="0">
                 <a:solidFill>
                   <a:srgbClr val="0B1F3A"/>
@@ -14418,11 +14628,12 @@
                   <a:srgbClr val="0B1F3A"/>
                 </a:solidFill>
               </a:rPr>
-              <a:t>포트폴리오 10개사 scorecard</a:t>
+              <a:t>포트폴리오 10개사 Scorecard</a:t>
             </a:r>
           </a:p>
           <a:p xmlns:a="http://schemas.openxmlformats.org/drawingml/2006/main">
             <a:pPr algn="l">
+              <a:buNone/>
               <a:defRPr sz="1200" b="0">
                 <a:solidFill>
                   <a:srgbClr val="0B1F3A"/>
@@ -14539,6 +14750,7 @@
           <a:lstStyle xmlns:a="http://schemas.openxmlformats.org/drawingml/2006/main"/>
           <a:p xmlns:a="http://schemas.openxmlformats.org/drawingml/2006/main">
             <a:pPr algn="l">
+              <a:buNone/>
               <a:defRPr sz="1725" b="1">
                 <a:solidFill>
                   <a:srgbClr val="0B1F3A"/>
@@ -14589,6 +14801,7 @@
           <a:lstStyle xmlns:a="http://schemas.openxmlformats.org/drawingml/2006/main"/>
           <a:p xmlns:a="http://schemas.openxmlformats.org/drawingml/2006/main">
             <a:pPr algn="l">
+              <a:buNone/>
               <a:defRPr sz="1200" b="1">
                 <a:solidFill>
                   <a:srgbClr val="5C6B7A"/>
@@ -14639,6 +14852,7 @@
           <a:lstStyle xmlns:a="http://schemas.openxmlformats.org/drawingml/2006/main"/>
           <a:p xmlns:a="http://schemas.openxmlformats.org/drawingml/2006/main">
             <a:pPr algn="l">
+              <a:buNone/>
               <a:defRPr sz="1200" b="0">
                 <a:solidFill>
                   <a:srgbClr val="5C6B7A"/>
@@ -14689,6 +14903,7 @@
           <a:lstStyle xmlns:a="http://schemas.openxmlformats.org/drawingml/2006/main"/>
           <a:p xmlns:a="http://schemas.openxmlformats.org/drawingml/2006/main">
             <a:pPr algn="l">
+              <a:buNone/>
               <a:defRPr sz="1200" b="1">
                 <a:solidFill>
                   <a:srgbClr val="5C6B7A"/>
@@ -14739,6 +14954,7 @@
           <a:lstStyle xmlns:a="http://schemas.openxmlformats.org/drawingml/2006/main"/>
           <a:p xmlns:a="http://schemas.openxmlformats.org/drawingml/2006/main">
             <a:pPr algn="l">
+              <a:buNone/>
               <a:defRPr sz="1200" b="0">
                 <a:solidFill>
                   <a:srgbClr val="0B1F3A"/>
@@ -14756,6 +14972,7 @@
           </a:p>
           <a:p xmlns:a="http://schemas.openxmlformats.org/drawingml/2006/main">
             <a:pPr algn="l">
+              <a:buNone/>
               <a:defRPr sz="1200" b="0">
                 <a:solidFill>
                   <a:srgbClr val="0B1F3A"/>
@@ -14806,6 +15023,7 @@
           <a:lstStyle xmlns:a="http://schemas.openxmlformats.org/drawingml/2006/main"/>
           <a:p xmlns:a="http://schemas.openxmlformats.org/drawingml/2006/main">
             <a:pPr algn="ctr">
+              <a:buNone/>
               <a:defRPr sz="1800" b="1">
                 <a:solidFill>
                   <a:srgbClr val="0B1F3A"/>
@@ -14818,7 +15036,7 @@
                   <a:srgbClr val="0B1F3A"/>
                 </a:solidFill>
               </a:rPr>
-              <a:t>중요한 것은 지금 셋 중 하나를 찍는 것이 아니라, SV 안에서 ROI가 가장 큰 업무를 함께 찾는 것입니다.</a:t>
+              <a:t>중요한 것은 지금 셋 중 하나를 고르는 것이 아니라, SV 안에서 ROI가 가장 큰 업무를 함께 찾는 것입니다.</a:t>
             </a:r>
           </a:p>
         </p:txBody>

</xml_diff>

<commit_message>
Fix PPT word wrapping and remove page 10
</commit_message>
<xml_diff>
--- a/outputs/SV_AI_Native_90일_실행프로그램.pptx
+++ b/outputs/SV_AI_Native_90일_실행프로그램.pptx
@@ -2,24 +2,23 @@
 <file path=ppt/presentation.xml><?xml version="1.0" encoding="utf-8"?>
 <p:presentation xmlns:p="http://schemas.openxmlformats.org/presentationml/2006/main">
   <p:sldMasterIdLst>
-    <p:sldMasterId xmlns:r="http://schemas.openxmlformats.org/officeDocument/2006/relationships" id="2147483648" r:id="Rfba343f15b074f22"/>
+    <p:sldMasterId xmlns:r="http://schemas.openxmlformats.org/officeDocument/2006/relationships" id="2147483648" r:id="R3c319219046f4e35"/>
   </p:sldMasterIdLst>
   <p:notesMasterIdLst>
-    <p:notesMasterId xmlns:r="http://schemas.openxmlformats.org/officeDocument/2006/relationships" r:id="R7ebdc5ae4f4446b2"/>
+    <p:notesMasterId xmlns:r="http://schemas.openxmlformats.org/officeDocument/2006/relationships" r:id="R85889b624be34875"/>
   </p:notesMasterIdLst>
   <p:sldIdLst>
-    <p:sldId xmlns:r="http://schemas.openxmlformats.org/officeDocument/2006/relationships" id="256" r:id="R3598233a5fe1478e"/>
-    <p:sldId xmlns:r="http://schemas.openxmlformats.org/officeDocument/2006/relationships" id="257" r:id="R49c7da08a61349a4"/>
-    <p:sldId xmlns:r="http://schemas.openxmlformats.org/officeDocument/2006/relationships" id="258" r:id="R493bdbd3451b4b8d"/>
-    <p:sldId xmlns:r="http://schemas.openxmlformats.org/officeDocument/2006/relationships" id="259" r:id="R8da841f78b2448c9"/>
-    <p:sldId xmlns:r="http://schemas.openxmlformats.org/officeDocument/2006/relationships" id="260" r:id="R4c21c0be14be47b6"/>
-    <p:sldId xmlns:r="http://schemas.openxmlformats.org/officeDocument/2006/relationships" id="261" r:id="R29a40334cf814ce3"/>
-    <p:sldId xmlns:r="http://schemas.openxmlformats.org/officeDocument/2006/relationships" id="262" r:id="R4b44fd715b5045ef"/>
-    <p:sldId xmlns:r="http://schemas.openxmlformats.org/officeDocument/2006/relationships" id="263" r:id="R0b600a0b8c9b4504"/>
-    <p:sldId xmlns:r="http://schemas.openxmlformats.org/officeDocument/2006/relationships" id="264" r:id="R7008f562907e447e"/>
-    <p:sldId xmlns:r="http://schemas.openxmlformats.org/officeDocument/2006/relationships" id="265" r:id="Rf6b69a29f72a471b"/>
-    <p:sldId xmlns:r="http://schemas.openxmlformats.org/officeDocument/2006/relationships" id="266" r:id="R9ccf89de9deb46e7"/>
-    <p:sldId xmlns:r="http://schemas.openxmlformats.org/officeDocument/2006/relationships" id="267" r:id="Rcaa7130ebc184bfd"/>
+    <p:sldId xmlns:r="http://schemas.openxmlformats.org/officeDocument/2006/relationships" id="256" r:id="R9a929c2d49c448d0"/>
+    <p:sldId xmlns:r="http://schemas.openxmlformats.org/officeDocument/2006/relationships" id="257" r:id="Rabe27e1ea75e49a2"/>
+    <p:sldId xmlns:r="http://schemas.openxmlformats.org/officeDocument/2006/relationships" id="258" r:id="R37964f7ae04a45c3"/>
+    <p:sldId xmlns:r="http://schemas.openxmlformats.org/officeDocument/2006/relationships" id="259" r:id="R9c965f1934f54fe5"/>
+    <p:sldId xmlns:r="http://schemas.openxmlformats.org/officeDocument/2006/relationships" id="260" r:id="R3ad3b5486a954ef5"/>
+    <p:sldId xmlns:r="http://schemas.openxmlformats.org/officeDocument/2006/relationships" id="261" r:id="R464bc3f157e44183"/>
+    <p:sldId xmlns:r="http://schemas.openxmlformats.org/officeDocument/2006/relationships" id="262" r:id="R1c4084b2fce146d0"/>
+    <p:sldId xmlns:r="http://schemas.openxmlformats.org/officeDocument/2006/relationships" id="263" r:id="Rff2c8205ad374a44"/>
+    <p:sldId xmlns:r="http://schemas.openxmlformats.org/officeDocument/2006/relationships" id="264" r:id="R38134ec141254368"/>
+    <p:sldId xmlns:r="http://schemas.openxmlformats.org/officeDocument/2006/relationships" id="265" r:id="Rb30aaba8647a48b2"/>
+    <p:sldId xmlns:r="http://schemas.openxmlformats.org/officeDocument/2006/relationships" id="266" r:id="R0077cd6f21f14614"/>
   </p:sldIdLst>
   <p:sldSz cx="12192000" cy="6858000"/>
   <p:notesSz cx="6858000" cy="9144000"/>
@@ -706,72 +705,6 @@
 </p:notes>
 </file>
 
-<file path=ppt/notesSlides/notesSlide12.xml><?xml version="1.0" encoding="utf-8"?>
-<p:notes xmlns:p="http://schemas.openxmlformats.org/presentationml/2006/main">
-  <p:cSld>
-    <p:spTree>
-      <p:nvGrpSpPr>
-        <p:cNvPr id="1" name=""/>
-        <p:cNvGrpSpPr/>
-        <p:nvPr/>
-      </p:nvGrpSpPr>
-      <p:grpSpPr>
-        <a:xfrm xmlns:a="http://schemas.openxmlformats.org/drawingml/2006/main"/>
-      </p:grpSpPr>
-      <p:sp>
-        <p:nvSpPr>
-          <p:cNvPr id="2" name="Slide Image Placeholder 1"/>
-          <p:cNvSpPr>
-            <a:spLocks xmlns:a="http://schemas.openxmlformats.org/drawingml/2006/main" noGrp="1"/>
-          </p:cNvSpPr>
-          <p:nvPr>
-            <p:ph type="sldImg" idx="0"/>
-          </p:nvPr>
-        </p:nvSpPr>
-        <p:spPr/>
-      </p:sp>
-      <p:sp>
-        <p:nvSpPr>
-          <p:cNvPr id="3" name="Notes Placeholder 2"/>
-          <p:cNvSpPr>
-            <a:spLocks xmlns:a="http://schemas.openxmlformats.org/drawingml/2006/main" noGrp="1"/>
-          </p:cNvSpPr>
-          <p:nvPr>
-            <p:ph type="body" idx="1"/>
-          </p:nvPr>
-        </p:nvSpPr>
-        <p:spPr/>
-        <p:txBody>
-          <a:bodyPr xmlns:a="http://schemas.openxmlformats.org/drawingml/2006/main"/>
-          <a:lstStyle xmlns:a="http://schemas.openxmlformats.org/drawingml/2006/main"/>
-          <a:p xmlns:a="http://schemas.openxmlformats.org/drawingml/2006/main"/>
-        </p:txBody>
-      </p:sp>
-      <p:sp>
-        <p:nvSpPr>
-          <p:cNvPr id="4" name="Slide Number Placeholder 3"/>
-          <p:cNvSpPr>
-            <a:spLocks xmlns:a="http://schemas.openxmlformats.org/drawingml/2006/main" noGrp="1"/>
-          </p:cNvSpPr>
-          <p:nvPr>
-            <p:ph type="sldNum" idx="5"/>
-          </p:nvPr>
-        </p:nvSpPr>
-        <p:spPr/>
-        <p:txBody>
-          <a:bodyPr xmlns:a="http://schemas.openxmlformats.org/drawingml/2006/main"/>
-          <a:lstStyle xmlns:a="http://schemas.openxmlformats.org/drawingml/2006/main"/>
-          <a:p xmlns:a="http://schemas.openxmlformats.org/drawingml/2006/main"/>
-        </p:txBody>
-      </p:sp>
-    </p:spTree>
-  </p:cSld>
-  <p:clrMapOvr>
-    <a:masterClrMapping xmlns:a="http://schemas.openxmlformats.org/drawingml/2006/main"/>
-  </p:clrMapOvr>
-</p:notes>
-</file>
-
 <file path=ppt/notesSlides/notesSlide2.xml><?xml version="1.0" encoding="utf-8"?>
 <p:notes xmlns:p="http://schemas.openxmlformats.org/presentationml/2006/main">
   <p:cSld>
@@ -1338,7 +1271,7 @@
   </p:cSld>
   <p:clrMap bg1="lt1" tx1="dk1" bg2="lt2" tx2="dk2" accent1="accent1" accent2="accent2" accent3="accent3" accent4="accent4" accent5="accent5" accent6="accent6" hlink="hlink" folHlink="folHlink"/>
   <p:sldLayoutIdLst>
-    <p:sldLayoutId xmlns:r="http://schemas.openxmlformats.org/officeDocument/2006/relationships" id="2147483649" r:id="R6973991314c5452c"/>
+    <p:sldLayoutId xmlns:r="http://schemas.openxmlformats.org/officeDocument/2006/relationships" id="2147483649" r:id="R4438837b607b4232"/>
   </p:sldLayoutIdLst>
   <p:txStyles>
     <p:titleStyle>
@@ -2194,7 +2127,25 @@
                   <a:srgbClr val="5C6B7A"/>
                 </a:solidFill>
               </a:rPr>
-              <a:t>단순 PoC 제안이 아니라, SV 내부 실행 역량과 검증 가능한 산출물을 함께 만드는 전환 프로그램</a:t>
+              <a:t>단순 PoC 제안이 아니라, SV 내부 실행 역량과</a:t>
+            </a:r>
+          </a:p>
+          <a:p xmlns:a="http://schemas.openxmlformats.org/drawingml/2006/main">
+            <a:pPr algn="l">
+              <a:buNone/>
+              <a:defRPr sz="1650" b="0">
+                <a:solidFill>
+                  <a:srgbClr val="5C6B7A"/>
+                </a:solidFill>
+              </a:defRPr>
+            </a:pPr>
+            <a:r>
+              <a:rPr sz="1650" b="0">
+                <a:solidFill>
+                  <a:srgbClr val="5C6B7A"/>
+                </a:solidFill>
+              </a:rPr>
+              <a:t>검증 가능한 산출물을 함께 만드는 전환 프로그램</a:t>
             </a:r>
           </a:p>
         </p:txBody>
@@ -2284,7 +2235,7 @@
           <p:cNvPr id="1" name="">
             <a:extLst xmlns:a="http://schemas.openxmlformats.org/drawingml/2006/main">
               <a:ext uri="{FF2B5EF4-FFF2-40B4-BE49-F238E27FC236}">
-                <a16:creationId xmlns:a16="http://schemas.microsoft.com/office/drawing/2014/main" id="{1DE9B25D-B0DF-4294-98AF-7152E1E67C90}"/>
+                <a16:creationId xmlns:a16="http://schemas.microsoft.com/office/drawing/2014/main" id="{E70115FA-985F-4848-A727-46BC6C99F94D}"/>
               </a:ext>
             </a:extLst>
           </p:cNvPr>
@@ -2335,7 +2286,7 @@
           <p:cNvPr id="2" name="">
             <a:extLst xmlns:a="http://schemas.openxmlformats.org/drawingml/2006/main">
               <a:ext uri="{FF2B5EF4-FFF2-40B4-BE49-F238E27FC236}">
-                <a16:creationId xmlns:a16="http://schemas.microsoft.com/office/drawing/2014/main" id="{172BED70-11D7-48BE-89C2-BAA74309E6EA}"/>
+                <a16:creationId xmlns:a16="http://schemas.microsoft.com/office/drawing/2014/main" id="{09225B48-C0E1-4EE1-9C9F-307CA9431050}"/>
               </a:ext>
             </a:extLst>
           </p:cNvPr>
@@ -2376,7 +2327,7 @@
                   <a:srgbClr val="0B1F3A"/>
                 </a:solidFill>
               </a:rPr>
-              <a:t>SV 참여자별 역할과 효익</a:t>
+              <a:t>오늘 정할 후속 검토 사항</a:t>
             </a:r>
           </a:p>
         </p:txBody>
@@ -2386,7 +2337,7 @@
           <p:cNvPr id="3" name="">
             <a:extLst xmlns:a="http://schemas.openxmlformats.org/drawingml/2006/main">
               <a:ext uri="{FF2B5EF4-FFF2-40B4-BE49-F238E27FC236}">
-                <a16:creationId xmlns:a16="http://schemas.microsoft.com/office/drawing/2014/main" id="{D00A9A0E-8170-47E1-93E8-7A42849F52C5}"/>
+                <a16:creationId xmlns:a16="http://schemas.microsoft.com/office/drawing/2014/main" id="{4D5692FC-2E9F-4B12-B896-91F4658376BB}"/>
               </a:ext>
             </a:extLst>
           </p:cNvPr>
@@ -2417,7 +2368,7 @@
           <p:cNvPr id="4" name="">
             <a:extLst xmlns:a="http://schemas.openxmlformats.org/drawingml/2006/main">
               <a:ext uri="{FF2B5EF4-FFF2-40B4-BE49-F238E27FC236}">
-                <a16:creationId xmlns:a16="http://schemas.microsoft.com/office/drawing/2014/main" id="{5174178D-5896-47CF-9062-087F29DFAD1D}"/>
+                <a16:creationId xmlns:a16="http://schemas.microsoft.com/office/drawing/2014/main" id="{2890D49B-F8D5-4D79-9214-288016775DFB}"/>
               </a:ext>
             </a:extLst>
           </p:cNvPr>
@@ -2459,866 +2410,6 @@
                 </a:solidFill>
               </a:rPr>
               <a:t>10</a:t>
-            </a:r>
-          </a:p>
-        </p:txBody>
-      </p:sp>
-      <p:sp>
-        <p:nvSpPr>
-          <p:cNvPr id="5" name="">
-            <a:extLst xmlns:a="http://schemas.openxmlformats.org/drawingml/2006/main">
-              <a:ext uri="{FF2B5EF4-FFF2-40B4-BE49-F238E27FC236}">
-                <a16:creationId xmlns:a16="http://schemas.microsoft.com/office/drawing/2014/main" id="{19F448F1-DED4-42E9-978E-6155A4B5E39C}"/>
-              </a:ext>
-            </a:extLst>
-          </p:cNvPr>
-          <p:cNvSpPr>
-            <a:spLocks xmlns:a="http://schemas.openxmlformats.org/drawingml/2006/main" noGrp="1"/>
-          </p:cNvSpPr>
-          <p:nvPr/>
-        </p:nvSpPr>
-        <p:spPr>
-          <a:xfrm xmlns:a="http://schemas.openxmlformats.org/drawingml/2006/main">
-            <a:off x="9953625" y="6362700"/>
-            <a:ext cx="1524000" cy="228600"/>
-          </a:xfrm>
-          <a:prstGeom xmlns:a="http://schemas.openxmlformats.org/drawingml/2006/main" prst="rect">
-            <a:avLst/>
-          </a:prstGeom>
-          <a:noFill xmlns:a="http://schemas.openxmlformats.org/drawingml/2006/main"/>
-          <a:ln xmlns:a="http://schemas.openxmlformats.org/drawingml/2006/main" w="0">
-            <a:noFill/>
-            <a:prstDash val="solid"/>
-          </a:ln>
-        </p:spPr>
-        <p:txBody>
-          <a:bodyPr xmlns:a="http://schemas.openxmlformats.org/drawingml/2006/main"/>
-          <a:lstStyle xmlns:a="http://schemas.openxmlformats.org/drawingml/2006/main"/>
-          <a:p xmlns:a="http://schemas.openxmlformats.org/drawingml/2006/main">
-            <a:pPr algn="r">
-              <a:buNone/>
-              <a:defRPr sz="1200" b="1">
-                <a:solidFill>
-                  <a:srgbClr val="0B1F3A"/>
-                </a:solidFill>
-              </a:defRPr>
-            </a:pPr>
-            <a:r>
-              <a:rPr sz="1200" b="1">
-                <a:solidFill>
-                  <a:srgbClr val="0B1F3A"/>
-                </a:solidFill>
-              </a:rPr>
-              <a:t>magicecole</a:t>
-            </a:r>
-          </a:p>
-        </p:txBody>
-      </p:sp>
-      <p:sp>
-        <p:nvSpPr>
-          <p:cNvPr id="6" name="">
-            <a:extLst xmlns:a="http://schemas.openxmlformats.org/drawingml/2006/main">
-              <a:ext uri="{FF2B5EF4-FFF2-40B4-BE49-F238E27FC236}">
-                <a16:creationId xmlns:a16="http://schemas.microsoft.com/office/drawing/2014/main" id="{2E4CD3DB-444E-43C7-A1AE-23FDC23A6129}"/>
-              </a:ext>
-            </a:extLst>
-          </p:cNvPr>
-          <p:cNvSpPr>
-            <a:spLocks xmlns:a="http://schemas.openxmlformats.org/drawingml/2006/main" noGrp="1"/>
-          </p:cNvSpPr>
-          <p:nvPr/>
-        </p:nvSpPr>
-        <p:spPr>
-          <a:xfrm xmlns:a="http://schemas.openxmlformats.org/drawingml/2006/main">
-            <a:off x="666750" y="6191250"/>
-            <a:ext cx="10858500" cy="11430"/>
-          </a:xfrm>
-          <a:prstGeom xmlns:a="http://schemas.openxmlformats.org/drawingml/2006/main" prst="rect">
-            <a:avLst/>
-          </a:prstGeom>
-          <a:solidFill xmlns:a="http://schemas.openxmlformats.org/drawingml/2006/main">
-            <a:srgbClr val="D7E2F1"/>
-          </a:solidFill>
-          <a:ln xmlns:a="http://schemas.openxmlformats.org/drawingml/2006/main" w="0">
-            <a:noFill/>
-            <a:prstDash val="solid"/>
-          </a:ln>
-        </p:spPr>
-      </p:sp>
-      <p:sp>
-        <p:nvSpPr>
-          <p:cNvPr id="7" name="">
-            <a:extLst xmlns:a="http://schemas.openxmlformats.org/drawingml/2006/main">
-              <a:ext uri="{FF2B5EF4-FFF2-40B4-BE49-F238E27FC236}">
-                <a16:creationId xmlns:a16="http://schemas.microsoft.com/office/drawing/2014/main" id="{E9C38ACB-F9F3-4CB3-85A9-D73A524FDA80}"/>
-              </a:ext>
-            </a:extLst>
-          </p:cNvPr>
-          <p:cNvSpPr>
-            <a:spLocks xmlns:a="http://schemas.openxmlformats.org/drawingml/2006/main" noGrp="1"/>
-          </p:cNvSpPr>
-          <p:nvPr/>
-        </p:nvSpPr>
-        <p:spPr>
-          <a:xfrm xmlns:a="http://schemas.openxmlformats.org/drawingml/2006/main">
-            <a:off x="666750" y="6305550"/>
-            <a:ext cx="4953000" cy="209550"/>
-          </a:xfrm>
-          <a:prstGeom xmlns:a="http://schemas.openxmlformats.org/drawingml/2006/main" prst="rect">
-            <a:avLst/>
-          </a:prstGeom>
-          <a:noFill xmlns:a="http://schemas.openxmlformats.org/drawingml/2006/main"/>
-          <a:ln xmlns:a="http://schemas.openxmlformats.org/drawingml/2006/main" w="0">
-            <a:noFill/>
-            <a:prstDash val="solid"/>
-          </a:ln>
-        </p:spPr>
-        <p:txBody>
-          <a:bodyPr xmlns:a="http://schemas.openxmlformats.org/drawingml/2006/main"/>
-          <a:lstStyle xmlns:a="http://schemas.openxmlformats.org/drawingml/2006/main"/>
-          <a:p xmlns:a="http://schemas.openxmlformats.org/drawingml/2006/main">
-            <a:pPr algn="l">
-              <a:buNone/>
-              <a:defRPr sz="975" b="0">
-                <a:solidFill>
-                  <a:srgbClr val="5C6B7A"/>
-                </a:solidFill>
-              </a:defRPr>
-            </a:pPr>
-            <a:r>
-              <a:rPr sz="975" b="0">
-                <a:solidFill>
-                  <a:srgbClr val="5C6B7A"/>
-                </a:solidFill>
-              </a:rPr>
-              <a:t>90일 AI Native 실행 프로그램</a:t>
-            </a:r>
-          </a:p>
-        </p:txBody>
-      </p:sp>
-      <p:sp>
-        <p:nvSpPr>
-          <p:cNvPr id="8" name="">
-            <a:extLst xmlns:a="http://schemas.openxmlformats.org/drawingml/2006/main">
-              <a:ext uri="{FF2B5EF4-FFF2-40B4-BE49-F238E27FC236}">
-                <a16:creationId xmlns:a16="http://schemas.microsoft.com/office/drawing/2014/main" id="{1D5C6055-4630-48BA-BA1B-77C518B03B39}"/>
-              </a:ext>
-            </a:extLst>
-          </p:cNvPr>
-          <p:cNvSpPr>
-            <a:spLocks xmlns:a="http://schemas.openxmlformats.org/drawingml/2006/main" noGrp="1"/>
-          </p:cNvSpPr>
-          <p:nvPr/>
-        </p:nvSpPr>
-        <p:spPr>
-          <a:xfrm xmlns:a="http://schemas.openxmlformats.org/drawingml/2006/main">
-            <a:off x="952500" y="1809750"/>
-            <a:ext cx="3048000" cy="2667000"/>
-          </a:xfrm>
-          <a:prstGeom xmlns:a="http://schemas.openxmlformats.org/drawingml/2006/main" prst="roundRect">
-            <a:avLst>
-              <a:gd name="adj" fmla="val 4286"/>
-            </a:avLst>
-          </a:prstGeom>
-          <a:solidFill xmlns:a="http://schemas.openxmlformats.org/drawingml/2006/main">
-            <a:srgbClr val="FFFFFF"/>
-          </a:solidFill>
-          <a:ln xmlns:a="http://schemas.openxmlformats.org/drawingml/2006/main" w="9525">
-            <a:solidFill>
-              <a:srgbClr val="D7E2F1"/>
-            </a:solidFill>
-            <a:prstDash val="solid"/>
-          </a:ln>
-        </p:spPr>
-      </p:sp>
-      <p:sp>
-        <p:nvSpPr>
-          <p:cNvPr id="9" name="">
-            <a:extLst xmlns:a="http://schemas.openxmlformats.org/drawingml/2006/main">
-              <a:ext uri="{FF2B5EF4-FFF2-40B4-BE49-F238E27FC236}">
-                <a16:creationId xmlns:a16="http://schemas.microsoft.com/office/drawing/2014/main" id="{4EAAE9BF-11E7-4119-BAF8-E51F4F7117F6}"/>
-              </a:ext>
-            </a:extLst>
-          </p:cNvPr>
-          <p:cNvSpPr>
-            <a:spLocks xmlns:a="http://schemas.openxmlformats.org/drawingml/2006/main" noGrp="1"/>
-          </p:cNvSpPr>
-          <p:nvPr/>
-        </p:nvSpPr>
-        <p:spPr>
-          <a:xfrm xmlns:a="http://schemas.openxmlformats.org/drawingml/2006/main">
-            <a:off x="1200150" y="2143125"/>
-            <a:ext cx="2571750" cy="342900"/>
-          </a:xfrm>
-          <a:prstGeom xmlns:a="http://schemas.openxmlformats.org/drawingml/2006/main" prst="rect">
-            <a:avLst/>
-          </a:prstGeom>
-          <a:noFill xmlns:a="http://schemas.openxmlformats.org/drawingml/2006/main"/>
-          <a:ln xmlns:a="http://schemas.openxmlformats.org/drawingml/2006/main" w="0">
-            <a:noFill/>
-            <a:prstDash val="solid"/>
-          </a:ln>
-        </p:spPr>
-        <p:txBody>
-          <a:bodyPr xmlns:a="http://schemas.openxmlformats.org/drawingml/2006/main"/>
-          <a:lstStyle xmlns:a="http://schemas.openxmlformats.org/drawingml/2006/main"/>
-          <a:p xmlns:a="http://schemas.openxmlformats.org/drawingml/2006/main">
-            <a:pPr algn="l">
-              <a:buNone/>
-              <a:defRPr sz="2100" b="1">
-                <a:solidFill>
-                  <a:srgbClr val="0B1F3A"/>
-                </a:solidFill>
-              </a:defRPr>
-            </a:pPr>
-            <a:r>
-              <a:rPr sz="2100" b="1">
-                <a:solidFill>
-                  <a:srgbClr val="0B1F3A"/>
-                </a:solidFill>
-              </a:rPr>
-              <a:t>심사역</a:t>
-            </a:r>
-          </a:p>
-        </p:txBody>
-      </p:sp>
-      <p:sp>
-        <p:nvSpPr>
-          <p:cNvPr id="10" name="">
-            <a:extLst xmlns:a="http://schemas.openxmlformats.org/drawingml/2006/main">
-              <a:ext uri="{FF2B5EF4-FFF2-40B4-BE49-F238E27FC236}">
-                <a16:creationId xmlns:a16="http://schemas.microsoft.com/office/drawing/2014/main" id="{B1CE476B-83D7-4F49-89BB-BE325AE31F6E}"/>
-              </a:ext>
-            </a:extLst>
-          </p:cNvPr>
-          <p:cNvSpPr>
-            <a:spLocks xmlns:a="http://schemas.openxmlformats.org/drawingml/2006/main" noGrp="1"/>
-          </p:cNvSpPr>
-          <p:nvPr/>
-        </p:nvSpPr>
-        <p:spPr>
-          <a:xfrm xmlns:a="http://schemas.openxmlformats.org/drawingml/2006/main">
-            <a:off x="1200150" y="2809875"/>
-            <a:ext cx="2533650" cy="1066800"/>
-          </a:xfrm>
-          <a:prstGeom xmlns:a="http://schemas.openxmlformats.org/drawingml/2006/main" prst="rect">
-            <a:avLst/>
-          </a:prstGeom>
-          <a:noFill xmlns:a="http://schemas.openxmlformats.org/drawingml/2006/main"/>
-          <a:ln xmlns:a="http://schemas.openxmlformats.org/drawingml/2006/main" w="0">
-            <a:noFill/>
-            <a:prstDash val="solid"/>
-          </a:ln>
-        </p:spPr>
-        <p:txBody>
-          <a:bodyPr xmlns:a="http://schemas.openxmlformats.org/drawingml/2006/main"/>
-          <a:lstStyle xmlns:a="http://schemas.openxmlformats.org/drawingml/2006/main"/>
-          <a:p xmlns:a="http://schemas.openxmlformats.org/drawingml/2006/main">
-            <a:pPr algn="l">
-              <a:buNone/>
-              <a:defRPr sz="1425" b="0">
-                <a:solidFill>
-                  <a:srgbClr val="5C6B7A"/>
-                </a:solidFill>
-              </a:defRPr>
-            </a:pPr>
-            <a:r>
-              <a:rPr sz="1425" b="0">
-                <a:solidFill>
-                  <a:srgbClr val="5C6B7A"/>
-                </a:solidFill>
-              </a:rPr>
-              <a:t>내 업무를 AI가 보조할 수 있는 단위로 나누는 법을 배웁니다.</a:t>
-            </a:r>
-          </a:p>
-          <a:p xmlns:a="http://schemas.openxmlformats.org/drawingml/2006/main">
-            <a:pPr algn="l">
-              <a:buNone/>
-              <a:defRPr sz="1425" b="0">
-                <a:solidFill>
-                  <a:srgbClr val="5C6B7A"/>
-                </a:solidFill>
-              </a:defRPr>
-            </a:pPr>
-            <a:r>
-              <a:rPr sz="1425" b="0">
-                <a:solidFill>
-                  <a:srgbClr val="5C6B7A"/>
-                </a:solidFill>
-              </a:rPr>
-              <a:t>시장조사, 질문 리스트, IC 메모에서 체감합니다.</a:t>
-            </a:r>
-          </a:p>
-        </p:txBody>
-      </p:sp>
-      <p:sp>
-        <p:nvSpPr>
-          <p:cNvPr id="11" name="">
-            <a:extLst xmlns:a="http://schemas.openxmlformats.org/drawingml/2006/main">
-              <a:ext uri="{FF2B5EF4-FFF2-40B4-BE49-F238E27FC236}">
-                <a16:creationId xmlns:a16="http://schemas.microsoft.com/office/drawing/2014/main" id="{BDEE2123-D204-4293-98A5-F57E073F8BE6}"/>
-              </a:ext>
-            </a:extLst>
-          </p:cNvPr>
-          <p:cNvSpPr>
-            <a:spLocks xmlns:a="http://schemas.openxmlformats.org/drawingml/2006/main" noGrp="1"/>
-          </p:cNvSpPr>
-          <p:nvPr/>
-        </p:nvSpPr>
-        <p:spPr>
-          <a:xfrm xmlns:a="http://schemas.openxmlformats.org/drawingml/2006/main">
-            <a:off x="4476750" y="1809750"/>
-            <a:ext cx="3048000" cy="2667000"/>
-          </a:xfrm>
-          <a:prstGeom xmlns:a="http://schemas.openxmlformats.org/drawingml/2006/main" prst="roundRect">
-            <a:avLst>
-              <a:gd name="adj" fmla="val 4286"/>
-            </a:avLst>
-          </a:prstGeom>
-          <a:solidFill xmlns:a="http://schemas.openxmlformats.org/drawingml/2006/main">
-            <a:srgbClr val="FFFFFF"/>
-          </a:solidFill>
-          <a:ln xmlns:a="http://schemas.openxmlformats.org/drawingml/2006/main" w="9525">
-            <a:solidFill>
-              <a:srgbClr val="D7E2F1"/>
-            </a:solidFill>
-            <a:prstDash val="solid"/>
-          </a:ln>
-        </p:spPr>
-      </p:sp>
-      <p:sp>
-        <p:nvSpPr>
-          <p:cNvPr id="12" name="">
-            <a:extLst xmlns:a="http://schemas.openxmlformats.org/drawingml/2006/main">
-              <a:ext uri="{FF2B5EF4-FFF2-40B4-BE49-F238E27FC236}">
-                <a16:creationId xmlns:a16="http://schemas.microsoft.com/office/drawing/2014/main" id="{492BF47C-DB9D-425D-A892-35DD86974615}"/>
-              </a:ext>
-            </a:extLst>
-          </p:cNvPr>
-          <p:cNvSpPr>
-            <a:spLocks xmlns:a="http://schemas.openxmlformats.org/drawingml/2006/main" noGrp="1"/>
-          </p:cNvSpPr>
-          <p:nvPr/>
-        </p:nvSpPr>
-        <p:spPr>
-          <a:xfrm xmlns:a="http://schemas.openxmlformats.org/drawingml/2006/main">
-            <a:off x="4724400" y="2143125"/>
-            <a:ext cx="2571750" cy="342900"/>
-          </a:xfrm>
-          <a:prstGeom xmlns:a="http://schemas.openxmlformats.org/drawingml/2006/main" prst="rect">
-            <a:avLst/>
-          </a:prstGeom>
-          <a:noFill xmlns:a="http://schemas.openxmlformats.org/drawingml/2006/main"/>
-          <a:ln xmlns:a="http://schemas.openxmlformats.org/drawingml/2006/main" w="0">
-            <a:noFill/>
-            <a:prstDash val="solid"/>
-          </a:ln>
-        </p:spPr>
-        <p:txBody>
-          <a:bodyPr xmlns:a="http://schemas.openxmlformats.org/drawingml/2006/main"/>
-          <a:lstStyle xmlns:a="http://schemas.openxmlformats.org/drawingml/2006/main"/>
-          <a:p xmlns:a="http://schemas.openxmlformats.org/drawingml/2006/main">
-            <a:pPr algn="l">
-              <a:buNone/>
-              <a:defRPr sz="2100" b="1">
-                <a:solidFill>
-                  <a:srgbClr val="0B1F3A"/>
-                </a:solidFill>
-              </a:defRPr>
-            </a:pPr>
-            <a:r>
-              <a:rPr sz="2100" b="1">
-                <a:solidFill>
-                  <a:srgbClr val="0B1F3A"/>
-                </a:solidFill>
-              </a:rPr>
-              <a:t>스태프 조직</a:t>
-            </a:r>
-          </a:p>
-        </p:txBody>
-      </p:sp>
-      <p:sp>
-        <p:nvSpPr>
-          <p:cNvPr id="13" name="">
-            <a:extLst xmlns:a="http://schemas.openxmlformats.org/drawingml/2006/main">
-              <a:ext uri="{FF2B5EF4-FFF2-40B4-BE49-F238E27FC236}">
-                <a16:creationId xmlns:a16="http://schemas.microsoft.com/office/drawing/2014/main" id="{376EE730-7D69-4678-AE7A-CFFE1E1CC595}"/>
-              </a:ext>
-            </a:extLst>
-          </p:cNvPr>
-          <p:cNvSpPr>
-            <a:spLocks xmlns:a="http://schemas.openxmlformats.org/drawingml/2006/main" noGrp="1"/>
-          </p:cNvSpPr>
-          <p:nvPr/>
-        </p:nvSpPr>
-        <p:spPr>
-          <a:xfrm xmlns:a="http://schemas.openxmlformats.org/drawingml/2006/main">
-            <a:off x="4724400" y="2809875"/>
-            <a:ext cx="2533650" cy="1066800"/>
-          </a:xfrm>
-          <a:prstGeom xmlns:a="http://schemas.openxmlformats.org/drawingml/2006/main" prst="rect">
-            <a:avLst/>
-          </a:prstGeom>
-          <a:noFill xmlns:a="http://schemas.openxmlformats.org/drawingml/2006/main"/>
-          <a:ln xmlns:a="http://schemas.openxmlformats.org/drawingml/2006/main" w="0">
-            <a:noFill/>
-            <a:prstDash val="solid"/>
-          </a:ln>
-        </p:spPr>
-        <p:txBody>
-          <a:bodyPr xmlns:a="http://schemas.openxmlformats.org/drawingml/2006/main"/>
-          <a:lstStyle xmlns:a="http://schemas.openxmlformats.org/drawingml/2006/main"/>
-          <a:p xmlns:a="http://schemas.openxmlformats.org/drawingml/2006/main">
-            <a:pPr algn="l">
-              <a:buNone/>
-              <a:defRPr sz="1425" b="0">
-                <a:solidFill>
-                  <a:srgbClr val="5C6B7A"/>
-                </a:solidFill>
-              </a:defRPr>
-            </a:pPr>
-            <a:r>
-              <a:rPr sz="1425" b="0">
-                <a:solidFill>
-                  <a:srgbClr val="5C6B7A"/>
-                </a:solidFill>
-              </a:rPr>
-              <a:t>자료 취합, 보고, 회의체 운영을 구조화합니다.</a:t>
-            </a:r>
-          </a:p>
-          <a:p xmlns:a="http://schemas.openxmlformats.org/drawingml/2006/main">
-            <a:pPr algn="l">
-              <a:buNone/>
-              <a:defRPr sz="1425" b="0">
-                <a:solidFill>
-                  <a:srgbClr val="5C6B7A"/>
-                </a:solidFill>
-              </a:defRPr>
-            </a:pPr>
-            <a:r>
-              <a:rPr sz="1425" b="0">
-                <a:solidFill>
-                  <a:srgbClr val="5C6B7A"/>
-                </a:solidFill>
-              </a:rPr>
-              <a:t>보안, 템플릿, 로그 관리 기준을 맡습니다.</a:t>
-            </a:r>
-          </a:p>
-        </p:txBody>
-      </p:sp>
-      <p:sp>
-        <p:nvSpPr>
-          <p:cNvPr id="14" name="">
-            <a:extLst xmlns:a="http://schemas.openxmlformats.org/drawingml/2006/main">
-              <a:ext uri="{FF2B5EF4-FFF2-40B4-BE49-F238E27FC236}">
-                <a16:creationId xmlns:a16="http://schemas.microsoft.com/office/drawing/2014/main" id="{A7FFFE75-C0E0-49B8-ACD4-A7387FB182D3}"/>
-              </a:ext>
-            </a:extLst>
-          </p:cNvPr>
-          <p:cNvSpPr>
-            <a:spLocks xmlns:a="http://schemas.openxmlformats.org/drawingml/2006/main" noGrp="1"/>
-          </p:cNvSpPr>
-          <p:nvPr/>
-        </p:nvSpPr>
-        <p:spPr>
-          <a:xfrm xmlns:a="http://schemas.openxmlformats.org/drawingml/2006/main">
-            <a:off x="8001000" y="1809750"/>
-            <a:ext cx="3048000" cy="2667000"/>
-          </a:xfrm>
-          <a:prstGeom xmlns:a="http://schemas.openxmlformats.org/drawingml/2006/main" prst="roundRect">
-            <a:avLst>
-              <a:gd name="adj" fmla="val 4286"/>
-            </a:avLst>
-          </a:prstGeom>
-          <a:solidFill xmlns:a="http://schemas.openxmlformats.org/drawingml/2006/main">
-            <a:srgbClr val="0B1F3A"/>
-          </a:solidFill>
-          <a:ln xmlns:a="http://schemas.openxmlformats.org/drawingml/2006/main" w="0">
-            <a:noFill/>
-            <a:prstDash val="solid"/>
-          </a:ln>
-        </p:spPr>
-      </p:sp>
-      <p:sp>
-        <p:nvSpPr>
-          <p:cNvPr id="15" name="">
-            <a:extLst xmlns:a="http://schemas.openxmlformats.org/drawingml/2006/main">
-              <a:ext uri="{FF2B5EF4-FFF2-40B4-BE49-F238E27FC236}">
-                <a16:creationId xmlns:a16="http://schemas.microsoft.com/office/drawing/2014/main" id="{80C394D6-940A-4471-A95F-60B64089DDBD}"/>
-              </a:ext>
-            </a:extLst>
-          </p:cNvPr>
-          <p:cNvSpPr>
-            <a:spLocks xmlns:a="http://schemas.openxmlformats.org/drawingml/2006/main" noGrp="1"/>
-          </p:cNvSpPr>
-          <p:nvPr/>
-        </p:nvSpPr>
-        <p:spPr>
-          <a:xfrm xmlns:a="http://schemas.openxmlformats.org/drawingml/2006/main">
-            <a:off x="8248650" y="2143125"/>
-            <a:ext cx="2571750" cy="342900"/>
-          </a:xfrm>
-          <a:prstGeom xmlns:a="http://schemas.openxmlformats.org/drawingml/2006/main" prst="rect">
-            <a:avLst/>
-          </a:prstGeom>
-          <a:noFill xmlns:a="http://schemas.openxmlformats.org/drawingml/2006/main"/>
-          <a:ln xmlns:a="http://schemas.openxmlformats.org/drawingml/2006/main" w="0">
-            <a:noFill/>
-            <a:prstDash val="solid"/>
-          </a:ln>
-        </p:spPr>
-        <p:txBody>
-          <a:bodyPr xmlns:a="http://schemas.openxmlformats.org/drawingml/2006/main"/>
-          <a:lstStyle xmlns:a="http://schemas.openxmlformats.org/drawingml/2006/main"/>
-          <a:p xmlns:a="http://schemas.openxmlformats.org/drawingml/2006/main">
-            <a:pPr algn="l">
-              <a:buNone/>
-              <a:defRPr sz="2100" b="1">
-                <a:solidFill>
-                  <a:srgbClr val="FFFFFF"/>
-                </a:solidFill>
-              </a:defRPr>
-            </a:pPr>
-            <a:r>
-              <a:rPr sz="2100" b="1">
-                <a:solidFill>
-                  <a:srgbClr val="FFFFFF"/>
-                </a:solidFill>
-              </a:rPr>
-              <a:t>본부장/파트너</a:t>
-            </a:r>
-          </a:p>
-        </p:txBody>
-      </p:sp>
-      <p:sp>
-        <p:nvSpPr>
-          <p:cNvPr id="16" name="">
-            <a:extLst xmlns:a="http://schemas.openxmlformats.org/drawingml/2006/main">
-              <a:ext uri="{FF2B5EF4-FFF2-40B4-BE49-F238E27FC236}">
-                <a16:creationId xmlns:a16="http://schemas.microsoft.com/office/drawing/2014/main" id="{8EBAE421-ACF8-47AC-9BB6-909F8B47E0A7}"/>
-              </a:ext>
-            </a:extLst>
-          </p:cNvPr>
-          <p:cNvSpPr>
-            <a:spLocks xmlns:a="http://schemas.openxmlformats.org/drawingml/2006/main" noGrp="1"/>
-          </p:cNvSpPr>
-          <p:nvPr/>
-        </p:nvSpPr>
-        <p:spPr>
-          <a:xfrm xmlns:a="http://schemas.openxmlformats.org/drawingml/2006/main">
-            <a:off x="8248650" y="2809875"/>
-            <a:ext cx="2533650" cy="1066800"/>
-          </a:xfrm>
-          <a:prstGeom xmlns:a="http://schemas.openxmlformats.org/drawingml/2006/main" prst="rect">
-            <a:avLst/>
-          </a:prstGeom>
-          <a:noFill xmlns:a="http://schemas.openxmlformats.org/drawingml/2006/main"/>
-          <a:ln xmlns:a="http://schemas.openxmlformats.org/drawingml/2006/main" w="0">
-            <a:noFill/>
-            <a:prstDash val="solid"/>
-          </a:ln>
-        </p:spPr>
-        <p:txBody>
-          <a:bodyPr xmlns:a="http://schemas.openxmlformats.org/drawingml/2006/main"/>
-          <a:lstStyle xmlns:a="http://schemas.openxmlformats.org/drawingml/2006/main"/>
-          <a:p xmlns:a="http://schemas.openxmlformats.org/drawingml/2006/main">
-            <a:pPr algn="l">
-              <a:buNone/>
-              <a:defRPr sz="1425" b="0">
-                <a:solidFill>
-                  <a:srgbClr val="FFFFFF"/>
-                </a:solidFill>
-              </a:defRPr>
-            </a:pPr>
-            <a:r>
-              <a:rPr sz="1425" b="0">
-                <a:solidFill>
-                  <a:srgbClr val="FFFFFF"/>
-                </a:solidFill>
-              </a:rPr>
-              <a:t>일회성 교육이 아니라 내부 인력과 검증 산출물이 남습니다.</a:t>
-            </a:r>
-          </a:p>
-          <a:p xmlns:a="http://schemas.openxmlformats.org/drawingml/2006/main">
-            <a:pPr algn="l">
-              <a:buNone/>
-              <a:defRPr sz="1425" b="0">
-                <a:solidFill>
-                  <a:srgbClr val="FFFFFF"/>
-                </a:solidFill>
-              </a:defRPr>
-            </a:pPr>
-            <a:r>
-              <a:rPr sz="1425" b="0">
-                <a:solidFill>
-                  <a:srgbClr val="FFFFFF"/>
-                </a:solidFill>
-              </a:rPr>
-              <a:t>SV 내부 개선과 포트폴리오 확산을 함께 검증합니다.</a:t>
-            </a:r>
-          </a:p>
-        </p:txBody>
-      </p:sp>
-      <p:sp>
-        <p:nvSpPr>
-          <p:cNvPr id="17" name="">
-            <a:extLst xmlns:a="http://schemas.openxmlformats.org/drawingml/2006/main">
-              <a:ext uri="{FF2B5EF4-FFF2-40B4-BE49-F238E27FC236}">
-                <a16:creationId xmlns:a16="http://schemas.microsoft.com/office/drawing/2014/main" id="{69A179DB-ED41-4D99-B924-D38E9D831EB8}"/>
-              </a:ext>
-            </a:extLst>
-          </p:cNvPr>
-          <p:cNvSpPr>
-            <a:spLocks xmlns:a="http://schemas.openxmlformats.org/drawingml/2006/main" noGrp="1"/>
-          </p:cNvSpPr>
-          <p:nvPr/>
-        </p:nvSpPr>
-        <p:spPr>
-          <a:xfrm xmlns:a="http://schemas.openxmlformats.org/drawingml/2006/main">
-            <a:off x="1619250" y="5095875"/>
-            <a:ext cx="8953500" cy="400050"/>
-          </a:xfrm>
-          <a:prstGeom xmlns:a="http://schemas.openxmlformats.org/drawingml/2006/main" prst="rect">
-            <a:avLst/>
-          </a:prstGeom>
-          <a:noFill xmlns:a="http://schemas.openxmlformats.org/drawingml/2006/main"/>
-          <a:ln xmlns:a="http://schemas.openxmlformats.org/drawingml/2006/main" w="0">
-            <a:noFill/>
-            <a:prstDash val="solid"/>
-          </a:ln>
-        </p:spPr>
-        <p:txBody>
-          <a:bodyPr xmlns:a="http://schemas.openxmlformats.org/drawingml/2006/main"/>
-          <a:lstStyle xmlns:a="http://schemas.openxmlformats.org/drawingml/2006/main"/>
-          <a:p xmlns:a="http://schemas.openxmlformats.org/drawingml/2006/main">
-            <a:pPr algn="ctr">
-              <a:buNone/>
-              <a:defRPr sz="1875" b="1">
-                <a:solidFill>
-                  <a:srgbClr val="0E58C8"/>
-                </a:solidFill>
-              </a:defRPr>
-            </a:pPr>
-            <a:r>
-              <a:rPr sz="1875" b="1">
-                <a:solidFill>
-                  <a:srgbClr val="0E58C8"/>
-                </a:solidFill>
-              </a:rPr>
-              <a:t>각 참여자에게 역할과 효익이 보여야 실제 프로젝트로 전환됩니다.</a:t>
-            </a:r>
-          </a:p>
-        </p:txBody>
-      </p:sp>
-    </p:spTree>
-    <p:extLst>
-      <p:ext uri="{BB962C8B-B14F-4D97-AF65-F5344CB8AC3E}">
-        <p14:creationId xmlns:p14="http://schemas.microsoft.com/office/powerpoint/2010/main" val="1869997722"/>
-      </p:ext>
-    </p:extLst>
-  </p:cSld>
-</p:sld>
-</file>
-
-<file path=ppt/slides/slide11.xml><?xml version="1.0" encoding="utf-8"?>
-<p:sld xmlns:p="http://schemas.openxmlformats.org/presentationml/2006/main">
-  <p:cSld>
-    <p:bg>
-      <p:bgPr>
-        <a:solidFill xmlns:a="http://schemas.openxmlformats.org/drawingml/2006/main">
-          <a:srgbClr val="F4F7FC"/>
-        </a:solidFill>
-      </p:bgPr>
-    </p:bg>
-    <p:spTree>
-      <p:nvGrpSpPr>
-        <p:cNvPr id="1" name=""/>
-        <p:cNvGrpSpPr/>
-        <p:nvPr/>
-      </p:nvGrpSpPr>
-      <p:grpSpPr>
-        <a:xfrm xmlns:a="http://schemas.openxmlformats.org/drawingml/2006/main"/>
-      </p:grpSpPr>
-      <p:sp>
-        <p:nvSpPr>
-          <p:cNvPr id="1" name="">
-            <a:extLst xmlns:a="http://schemas.openxmlformats.org/drawingml/2006/main">
-              <a:ext uri="{FF2B5EF4-FFF2-40B4-BE49-F238E27FC236}">
-                <a16:creationId xmlns:a16="http://schemas.microsoft.com/office/drawing/2014/main" id="{E70115FA-985F-4848-A727-46BC6C99F94D}"/>
-              </a:ext>
-            </a:extLst>
-          </p:cNvPr>
-          <p:cNvSpPr>
-            <a:spLocks xmlns:a="http://schemas.openxmlformats.org/drawingml/2006/main" noGrp="1"/>
-          </p:cNvSpPr>
-          <p:nvPr/>
-        </p:nvSpPr>
-        <p:spPr>
-          <a:xfrm xmlns:a="http://schemas.openxmlformats.org/drawingml/2006/main">
-            <a:off x="666750" y="361950"/>
-            <a:ext cx="3048000" cy="228600"/>
-          </a:xfrm>
-          <a:prstGeom xmlns:a="http://schemas.openxmlformats.org/drawingml/2006/main" prst="rect">
-            <a:avLst/>
-          </a:prstGeom>
-          <a:noFill xmlns:a="http://schemas.openxmlformats.org/drawingml/2006/main"/>
-          <a:ln xmlns:a="http://schemas.openxmlformats.org/drawingml/2006/main" w="0">
-            <a:noFill/>
-            <a:prstDash val="solid"/>
-          </a:ln>
-        </p:spPr>
-        <p:txBody>
-          <a:bodyPr xmlns:a="http://schemas.openxmlformats.org/drawingml/2006/main"/>
-          <a:lstStyle xmlns:a="http://schemas.openxmlformats.org/drawingml/2006/main"/>
-          <a:p xmlns:a="http://schemas.openxmlformats.org/drawingml/2006/main">
-            <a:pPr algn="l">
-              <a:buNone/>
-              <a:defRPr sz="1050" b="1">
-                <a:solidFill>
-                  <a:srgbClr val="2F80ED"/>
-                </a:solidFill>
-              </a:defRPr>
-            </a:pPr>
-            <a:r>
-              <a:rPr sz="1050" b="1">
-                <a:solidFill>
-                  <a:srgbClr val="2F80ED"/>
-                </a:solidFill>
-              </a:rPr>
-              <a:t>SV AI Native VC</a:t>
-            </a:r>
-          </a:p>
-        </p:txBody>
-      </p:sp>
-      <p:sp>
-        <p:nvSpPr>
-          <p:cNvPr id="2" name="">
-            <a:extLst xmlns:a="http://schemas.openxmlformats.org/drawingml/2006/main">
-              <a:ext uri="{FF2B5EF4-FFF2-40B4-BE49-F238E27FC236}">
-                <a16:creationId xmlns:a16="http://schemas.microsoft.com/office/drawing/2014/main" id="{09225B48-C0E1-4EE1-9C9F-307CA9431050}"/>
-              </a:ext>
-            </a:extLst>
-          </p:cNvPr>
-          <p:cNvSpPr>
-            <a:spLocks xmlns:a="http://schemas.openxmlformats.org/drawingml/2006/main" noGrp="1"/>
-          </p:cNvSpPr>
-          <p:nvPr/>
-        </p:nvSpPr>
-        <p:spPr>
-          <a:xfrm xmlns:a="http://schemas.openxmlformats.org/drawingml/2006/main">
-            <a:off x="666750" y="666750"/>
-            <a:ext cx="8953500" cy="552450"/>
-          </a:xfrm>
-          <a:prstGeom xmlns:a="http://schemas.openxmlformats.org/drawingml/2006/main" prst="rect">
-            <a:avLst/>
-          </a:prstGeom>
-          <a:noFill xmlns:a="http://schemas.openxmlformats.org/drawingml/2006/main"/>
-          <a:ln xmlns:a="http://schemas.openxmlformats.org/drawingml/2006/main" w="0">
-            <a:noFill/>
-            <a:prstDash val="solid"/>
-          </a:ln>
-        </p:spPr>
-        <p:txBody>
-          <a:bodyPr xmlns:a="http://schemas.openxmlformats.org/drawingml/2006/main"/>
-          <a:lstStyle xmlns:a="http://schemas.openxmlformats.org/drawingml/2006/main"/>
-          <a:p xmlns:a="http://schemas.openxmlformats.org/drawingml/2006/main">
-            <a:pPr algn="l">
-              <a:buNone/>
-              <a:defRPr sz="2850" b="1">
-                <a:solidFill>
-                  <a:srgbClr val="0B1F3A"/>
-                </a:solidFill>
-              </a:defRPr>
-            </a:pPr>
-            <a:r>
-              <a:rPr sz="2850" b="1">
-                <a:solidFill>
-                  <a:srgbClr val="0B1F3A"/>
-                </a:solidFill>
-              </a:rPr>
-              <a:t>오늘 정할 후속 검토 사항</a:t>
-            </a:r>
-          </a:p>
-        </p:txBody>
-      </p:sp>
-      <p:sp>
-        <p:nvSpPr>
-          <p:cNvPr id="3" name="">
-            <a:extLst xmlns:a="http://schemas.openxmlformats.org/drawingml/2006/main">
-              <a:ext uri="{FF2B5EF4-FFF2-40B4-BE49-F238E27FC236}">
-                <a16:creationId xmlns:a16="http://schemas.microsoft.com/office/drawing/2014/main" id="{4D5692FC-2E9F-4B12-B896-91F4658376BB}"/>
-              </a:ext>
-            </a:extLst>
-          </p:cNvPr>
-          <p:cNvSpPr>
-            <a:spLocks xmlns:a="http://schemas.openxmlformats.org/drawingml/2006/main" noGrp="1"/>
-          </p:cNvSpPr>
-          <p:nvPr/>
-        </p:nvSpPr>
-        <p:spPr>
-          <a:xfrm xmlns:a="http://schemas.openxmlformats.org/drawingml/2006/main">
-            <a:off x="666750" y="1304925"/>
-            <a:ext cx="1562100" cy="38100"/>
-          </a:xfrm>
-          <a:prstGeom xmlns:a="http://schemas.openxmlformats.org/drawingml/2006/main" prst="rect">
-            <a:avLst/>
-          </a:prstGeom>
-          <a:solidFill xmlns:a="http://schemas.openxmlformats.org/drawingml/2006/main">
-            <a:srgbClr val="2F80ED"/>
-          </a:solidFill>
-          <a:ln xmlns:a="http://schemas.openxmlformats.org/drawingml/2006/main" w="0">
-            <a:noFill/>
-            <a:prstDash val="solid"/>
-          </a:ln>
-        </p:spPr>
-      </p:sp>
-      <p:sp>
-        <p:nvSpPr>
-          <p:cNvPr id="4" name="">
-            <a:extLst xmlns:a="http://schemas.openxmlformats.org/drawingml/2006/main">
-              <a:ext uri="{FF2B5EF4-FFF2-40B4-BE49-F238E27FC236}">
-                <a16:creationId xmlns:a16="http://schemas.microsoft.com/office/drawing/2014/main" id="{2890D49B-F8D5-4D79-9214-288016775DFB}"/>
-              </a:ext>
-            </a:extLst>
-          </p:cNvPr>
-          <p:cNvSpPr>
-            <a:spLocks xmlns:a="http://schemas.openxmlformats.org/drawingml/2006/main" noGrp="1"/>
-          </p:cNvSpPr>
-          <p:nvPr/>
-        </p:nvSpPr>
-        <p:spPr>
-          <a:xfrm xmlns:a="http://schemas.openxmlformats.org/drawingml/2006/main">
-            <a:off x="10763250" y="400050"/>
-            <a:ext cx="762000" cy="285750"/>
-          </a:xfrm>
-          <a:prstGeom xmlns:a="http://schemas.openxmlformats.org/drawingml/2006/main" prst="rect">
-            <a:avLst/>
-          </a:prstGeom>
-          <a:noFill xmlns:a="http://schemas.openxmlformats.org/drawingml/2006/main"/>
-          <a:ln xmlns:a="http://schemas.openxmlformats.org/drawingml/2006/main" w="0">
-            <a:noFill/>
-            <a:prstDash val="solid"/>
-          </a:ln>
-        </p:spPr>
-        <p:txBody>
-          <a:bodyPr xmlns:a="http://schemas.openxmlformats.org/drawingml/2006/main"/>
-          <a:lstStyle xmlns:a="http://schemas.openxmlformats.org/drawingml/2006/main"/>
-          <a:p xmlns:a="http://schemas.openxmlformats.org/drawingml/2006/main">
-            <a:pPr algn="r">
-              <a:buNone/>
-              <a:defRPr sz="1350" b="1">
-                <a:solidFill>
-                  <a:srgbClr val="2F80ED"/>
-                </a:solidFill>
-              </a:defRPr>
-            </a:pPr>
-            <a:r>
-              <a:rPr sz="1350" b="1">
-                <a:solidFill>
-                  <a:srgbClr val="2F80ED"/>
-                </a:solidFill>
-              </a:rPr>
-              <a:t>11</a:t>
             </a:r>
           </a:p>
         </p:txBody>
@@ -4098,7 +3189,7 @@
 </p:sld>
 </file>
 
-<file path=ppt/slides/slide12.xml><?xml version="1.0" encoding="utf-8"?>
+<file path=ppt/slides/slide11.xml><?xml version="1.0" encoding="utf-8"?>
 <p:sld xmlns:p="http://schemas.openxmlformats.org/presentationml/2006/main">
   <p:cSld>
     <p:bg>
@@ -5403,7 +4494,25 @@
                   <a:srgbClr val="0B1F3A"/>
                 </a:solidFill>
               </a:rPr>
-              <a:t>핵심은 시스템 납품이 아니라 내부 실행 역량과 검증 산출물을 같이 만드는 것입니다.</a:t>
+              <a:t>핵심은 시스템 납품이 아니라</a:t>
+            </a:r>
+          </a:p>
+          <a:p xmlns:a="http://schemas.openxmlformats.org/drawingml/2006/main">
+            <a:pPr algn="ctr">
+              <a:buNone/>
+              <a:defRPr sz="1875" b="1">
+                <a:solidFill>
+                  <a:srgbClr val="0B1F3A"/>
+                </a:solidFill>
+              </a:defRPr>
+            </a:pPr>
+            <a:r>
+              <a:rPr sz="1875" b="1">
+                <a:solidFill>
+                  <a:srgbClr val="0B1F3A"/>
+                </a:solidFill>
+              </a:rPr>
+              <a:t>내부 실행 역량과 검증 산출물을 같이 만드는 것입니다.</a:t>
             </a:r>
           </a:p>
         </p:txBody>
@@ -6457,7 +5566,25 @@
                   <a:srgbClr val="0E58C8"/>
                 </a:solidFill>
               </a:rPr>
-              <a:t>그래서 필요한 것은 단순 도구 도입이 아니라, 조직이 스스로 판단하고 운영할 수 있게 만드는 실행 체계입니다.</a:t>
+              <a:t>그래서 필요한 것은 단순 도구 도입이 아니라,</a:t>
+            </a:r>
+          </a:p>
+          <a:p xmlns:a="http://schemas.openxmlformats.org/drawingml/2006/main">
+            <a:pPr algn="ctr">
+              <a:buNone/>
+              <a:defRPr sz="1875" b="1">
+                <a:solidFill>
+                  <a:srgbClr val="0E58C8"/>
+                </a:solidFill>
+              </a:defRPr>
+            </a:pPr>
+            <a:r>
+              <a:rPr sz="1875" b="1">
+                <a:solidFill>
+                  <a:srgbClr val="0E58C8"/>
+                </a:solidFill>
+              </a:rPr>
+              <a:t>조직이 스스로 판단하고 운영할 수 있게 만드는 실행 체계입니다.</a:t>
             </a:r>
           </a:p>
         </p:txBody>
@@ -7813,7 +6940,25 @@
                   <a:srgbClr val="0B1F3A"/>
                 </a:solidFill>
               </a:rPr>
-              <a:t>단순 교육도, 외부 SI 구축도 아닙니다. 내부 업무를 아는 사람과 함께 검증 가능한 산출물을 만드는 방식입니다.</a:t>
+              <a:t>단순 교육도, 외부 SI 구축도 아닙니다.</a:t>
+            </a:r>
+          </a:p>
+          <a:p xmlns:a="http://schemas.openxmlformats.org/drawingml/2006/main">
+            <a:pPr algn="ctr">
+              <a:buNone/>
+              <a:defRPr sz="1875" b="1">
+                <a:solidFill>
+                  <a:srgbClr val="0B1F3A"/>
+                </a:solidFill>
+              </a:defRPr>
+            </a:pPr>
+            <a:r>
+              <a:rPr sz="1875" b="1">
+                <a:solidFill>
+                  <a:srgbClr val="0B1F3A"/>
+                </a:solidFill>
+              </a:rPr>
+              <a:t>내부 업무를 아는 사람과 함께 검증 가능한 산출물을 만드는 방식입니다.</a:t>
             </a:r>
           </a:p>
         </p:txBody>
@@ -12385,7 +11530,25 @@
                   <a:srgbClr val="0B1F3A"/>
                 </a:solidFill>
               </a:rPr>
-              <a:t>핵심 산출물은 도구 하나가 아니라, AI Native 방식으로 자기 업무를 정의하고 검증할 수 있는 내부 실행자입니다.</a:t>
+              <a:t>핵심 산출물은 도구 하나가 아니라,</a:t>
+            </a:r>
+          </a:p>
+          <a:p xmlns:a="http://schemas.openxmlformats.org/drawingml/2006/main">
+            <a:pPr algn="ctr">
+              <a:buNone/>
+              <a:defRPr sz="1800" b="1">
+                <a:solidFill>
+                  <a:srgbClr val="0B1F3A"/>
+                </a:solidFill>
+              </a:defRPr>
+            </a:pPr>
+            <a:r>
+              <a:rPr sz="1800" b="1">
+                <a:solidFill>
+                  <a:srgbClr val="0B1F3A"/>
+                </a:solidFill>
+              </a:rPr>
+              <a:t>AI Native 방식으로 자기 업무를 정의하고 검증할 수 있는 내부 실행자입니다.</a:t>
             </a:r>
           </a:p>
         </p:txBody>
@@ -13622,7 +12785,25 @@
                   <a:srgbClr val="0E58C8"/>
                 </a:solidFill>
               </a:rPr>
-              <a:t>이 역량이 남아야 이후 SV 내부 도입과 포트폴리오 확산이 반복 가능합니다.</a:t>
+              <a:t>이 역량이 남아야 이후 SV 내부 도입과</a:t>
+            </a:r>
+          </a:p>
+          <a:p xmlns:a="http://schemas.openxmlformats.org/drawingml/2006/main">
+            <a:pPr algn="ctr">
+              <a:buNone/>
+              <a:defRPr sz="1800" b="1">
+                <a:solidFill>
+                  <a:srgbClr val="0E58C8"/>
+                </a:solidFill>
+              </a:defRPr>
+            </a:pPr>
+            <a:r>
+              <a:rPr sz="1800" b="1">
+                <a:solidFill>
+                  <a:srgbClr val="0E58C8"/>
+                </a:solidFill>
+              </a:rPr>
+              <a:t>포트폴리오 확산이 반복 가능합니다.</a:t>
             </a:r>
           </a:p>
         </p:txBody>
@@ -15036,7 +14217,25 @@
                   <a:srgbClr val="0B1F3A"/>
                 </a:solidFill>
               </a:rPr>
-              <a:t>중요한 것은 지금 셋 중 하나를 고르는 것이 아니라, SV 안에서 ROI가 가장 큰 업무를 함께 찾는 것입니다.</a:t>
+              <a:t>중요한 것은 지금 셋 중 하나를 고르는 것이 아니라,</a:t>
+            </a:r>
+          </a:p>
+          <a:p xmlns:a="http://schemas.openxmlformats.org/drawingml/2006/main">
+            <a:pPr algn="ctr">
+              <a:buNone/>
+              <a:defRPr sz="1800" b="1">
+                <a:solidFill>
+                  <a:srgbClr val="0B1F3A"/>
+                </a:solidFill>
+              </a:defRPr>
+            </a:pPr>
+            <a:r>
+              <a:rPr sz="1800" b="1">
+                <a:solidFill>
+                  <a:srgbClr val="0B1F3A"/>
+                </a:solidFill>
+              </a:rPr>
+              <a:t>SV 안에서 ROI가 가장 큰 업무를 함께 찾는 것입니다.</a:t>
             </a:r>
           </a:p>
         </p:txBody>

</xml_diff>